<commit_message>
docs: replace fuzzy jargon with plain look-alike name language
Co-authored-by: Cursor <cursoragent@cursor.com>
</commit_message>
<xml_diff>
--- a/docs/reports/TradePulse_Young_Builders_Pitch_One_Slide.pptx
+++ b/docs/reports/TradePulse_Young_Builders_Pitch_One_Slide.pptx
@@ -3346,7 +3346,7 @@
                 </a:solidFill>
                 <a:latin typeface="Arial"/>
               </a:rPr>
-              <a:t>• Today: Staff still grind through invoice + shipping PDFs by hand; weak name matches get treated as “confirmed”; missing papers get waved through</a:t>
+              <a:t>• Today: Staff still grind through invoice + shipping PDFs by hand; a name that only looks alike gets treated as “confirmed”; missing papers get waved through</a:t>
             </a:r>
           </a:p>
           <a:p>
@@ -3605,7 +3605,7 @@
                 </a:solidFill>
                 <a:latin typeface="Arial"/>
               </a:rPr>
-              <a:t>• What we heard: Banks review the paperwork — they do not “see inside the container”; name similarity is not proof of who someone is</a:t>
+              <a:t>• What we heard: Banks review the paperwork — they do not “see inside the container”; a look-alike name is not proof of who someone is</a:t>
             </a:r>
           </a:p>
           <a:p>

</xml_diff>

<commit_message>
docs: visual Young Builders slide with flowchart and less text
Center the solution on a Papers → Check → Flag → Officer decides flow; shorten problem/proof/regulatory copy for scanability.

Co-authored-by: Cursor <cursoragent@cursor.com>
</commit_message>
<xml_diff>
--- a/docs/reports/TradePulse_Young_Builders_Pitch_One_Slide.pptx
+++ b/docs/reports/TradePulse_Young_Builders_Pitch_One_Slide.pptx
@@ -3096,8 +3096,8 @@
         </p:nvSpPr>
         <p:spPr>
           <a:xfrm>
-            <a:off x="320040" y="109728"/>
-            <a:ext cx="11551615" cy="347472"/>
+            <a:off x="292608" y="73152"/>
+            <a:ext cx="11606479" cy="292608"/>
           </a:xfrm>
           <a:prstGeom prst="rect">
             <a:avLst/>
@@ -3105,8 +3105,8 @@
           <a:noFill/>
         </p:spPr>
         <p:txBody>
-          <a:bodyPr wrap="square" lIns="73152" rIns="73152" tIns="54864" bIns="54864" anchor="t">
-            <a:noAutofit/>
+          <a:bodyPr wrap="square" lIns="73152" rIns="73152" anchor="t">
+            <a:spAutoFit/>
           </a:bodyPr>
           <a:lstStyle/>
           <a:p>
@@ -3119,7 +3119,7 @@
               </a:spcAft>
             </a:pPr>
             <a:r>
-              <a:rPr sz="1600" b="1" i="0">
+              <a:rPr sz="1500" b="1" i="0">
                 <a:solidFill>
                   <a:srgbClr val="000000"/>
                 </a:solidFill>
@@ -3138,8 +3138,107 @@
         </p:nvSpPr>
         <p:spPr>
           <a:xfrm>
-            <a:off x="320040" y="475488"/>
-            <a:ext cx="11551615" cy="960120"/>
+            <a:off x="292608" y="365760"/>
+            <a:ext cx="11606479" cy="658368"/>
+          </a:xfrm>
+          <a:prstGeom prst="rect">
+            <a:avLst/>
+          </a:prstGeom>
+          <a:solidFill>
+            <a:srgbClr val="F4F7FA"/>
+          </a:solidFill>
+          <a:ln w="12700">
+            <a:solidFill>
+              <a:srgbClr val="0B1F33"/>
+            </a:solidFill>
+          </a:ln>
+        </p:spPr>
+        <p:style>
+          <a:lnRef idx="1">
+            <a:schemeClr val="accent1"/>
+          </a:lnRef>
+          <a:fillRef idx="3">
+            <a:schemeClr val="accent1"/>
+          </a:fillRef>
+          <a:effectRef idx="2">
+            <a:schemeClr val="accent1"/>
+          </a:effectRef>
+          <a:fontRef idx="minor">
+            <a:schemeClr val="lt1"/>
+          </a:fontRef>
+        </p:style>
+        <p:txBody>
+          <a:bodyPr rtlCol="0" anchor="t" wrap="square" lIns="73152" rIns="73152"/>
+          <a:lstStyle/>
+          <a:p>
+            <a:pPr algn="ctr">
+              <a:spcBef>
+                <a:spcPts val="0"/>
+              </a:spcBef>
+              <a:spcAft>
+                <a:spcPts val="300"/>
+              </a:spcAft>
+            </a:pPr>
+            <a:r>
+              <a:rPr sz="1100" b="1" i="0">
+                <a:solidFill>
+                  <a:srgbClr val="0B1F33"/>
+                </a:solidFill>
+                <a:latin typeface="Arial"/>
+              </a:rPr>
+              <a:t>Pitch Snapshot</a:t>
+            </a:r>
+          </a:p>
+          <a:p>
+            <a:pPr algn="ctr">
+              <a:spcBef>
+                <a:spcPts val="0"/>
+              </a:spcBef>
+              <a:spcAft>
+                <a:spcPts val="200"/>
+              </a:spcAft>
+            </a:pPr>
+            <a:r>
+              <a:rPr sz="900" b="0" i="0">
+                <a:solidFill>
+                  <a:srgbClr val="000000"/>
+                </a:solidFill>
+                <a:latin typeface="Arial"/>
+              </a:rPr>
+              <a:t>TradePulse  ·  Track 1 — Agentic AI  ·  Bank / GIFT trade officers review documents faster &amp; safer</a:t>
+            </a:r>
+          </a:p>
+          <a:p>
+            <a:pPr algn="ctr">
+              <a:spcBef>
+                <a:spcPts val="0"/>
+              </a:spcBef>
+              <a:spcAft>
+                <a:spcPts val="0"/>
+              </a:spcAft>
+            </a:pPr>
+            <a:r>
+              <a:rPr sz="850" b="0" i="0">
+                <a:solidFill>
+                  <a:srgbClr val="000000"/>
+                </a:solidFill>
+                <a:latin typeface="Arial"/>
+              </a:rPr>
+              <a:t>Stage: □ Idea   ■ Prototype   □ MVP   □ Pilot     |     Commitment: □ Full-time   ■ Part-time</a:t>
+            </a:r>
+          </a:p>
+        </p:txBody>
+      </p:sp>
+      <p:sp>
+        <p:nvSpPr>
+          <p:cNvPr id="4" name="Rectangle 3"/>
+          <p:cNvSpPr/>
+          <p:nvPr/>
+        </p:nvSpPr>
+        <p:spPr>
+          <a:xfrm>
+            <a:off x="292608" y="1115568"/>
+            <a:ext cx="2880360" cy="2788920"/>
           </a:xfrm>
           <a:prstGeom prst="rect">
             <a:avLst/>
@@ -3168,27 +3267,25 @@
           </a:fontRef>
         </p:style>
         <p:txBody>
-          <a:bodyPr rtlCol="0" anchor="t" wrap="square" lIns="73152" rIns="73152" tIns="54864" bIns="54864">
-            <a:noAutofit/>
-          </a:bodyPr>
-          <a:lstStyle/>
-          <a:p>
-            <a:pPr algn="ctr">
+          <a:bodyPr rtlCol="0" anchor="t" wrap="square" lIns="73152" rIns="73152"/>
+          <a:lstStyle/>
+          <a:p>
+            <a:pPr algn="l">
               <a:spcBef>
                 <a:spcPts val="0"/>
               </a:spcBef>
               <a:spcAft>
-                <a:spcPts val="600"/>
+                <a:spcPts val="800"/>
               </a:spcAft>
             </a:pPr>
             <a:r>
               <a:rPr sz="1200" b="1" i="0">
                 <a:solidFill>
-                  <a:srgbClr val="000000"/>
+                  <a:srgbClr val="0B1F33"/>
                 </a:solidFill>
                 <a:latin typeface="Arial"/>
               </a:rPr>
-              <a:t>Pitch Snapshot</a:t>
+              <a:t>1. Problem</a:t>
             </a:r>
           </a:p>
           <a:p>
@@ -3197,17 +3294,17 @@
                 <a:spcPts val="0"/>
               </a:spcBef>
               <a:spcAft>
-                <a:spcPts val="300"/>
+                <a:spcPts val="200"/>
               </a:spcAft>
             </a:pPr>
             <a:r>
-              <a:rPr sz="900" b="0" i="0">
-                <a:solidFill>
-                  <a:srgbClr val="000000"/>
+              <a:rPr sz="900" b="1" i="0">
+                <a:solidFill>
+                  <a:srgbClr val="E9631D"/>
                 </a:solidFill>
                 <a:latin typeface="Arial"/>
               </a:rPr>
-              <a:t>• Team Name: TradePulse  |  Track: Track 1 — Agentic AI  |  Focus: Helping bank / GIFT trade officers review trade documents faster and safer</a:t>
+              <a:t>Who</a:t>
             </a:r>
           </a:p>
           <a:p>
@@ -3216,7 +3313,7 @@
                 <a:spcPts val="0"/>
               </a:spcBef>
               <a:spcAft>
-                <a:spcPts val="300"/>
+                <a:spcPts val="800"/>
               </a:spcAft>
             </a:pPr>
             <a:r>
@@ -3226,7 +3323,7 @@
                 </a:solidFill>
                 <a:latin typeface="Arial"/>
               </a:rPr>
-              <a:t>• Stage: □ Idea   ■ Prototype   □ MVP   □ Pilot</a:t>
+              <a:t>Head of Trade Finance Ops at a GIFT City IBU / bank desk</a:t>
             </a:r>
           </a:p>
           <a:p>
@@ -3235,31 +3332,88 @@
                 <a:spcPts val="0"/>
               </a:spcBef>
               <a:spcAft>
-                <a:spcPts val="0"/>
+                <a:spcPts val="200"/>
               </a:spcAft>
             </a:pPr>
             <a:r>
-              <a:rPr sz="900" b="0" i="0">
-                <a:solidFill>
-                  <a:srgbClr val="000000"/>
+              <a:rPr sz="900" b="1" i="0">
+                <a:solidFill>
+                  <a:srgbClr val="E9631D"/>
                 </a:solidFill>
                 <a:latin typeface="Arial"/>
               </a:rPr>
-              <a:t>• Team Commitment: □ Full-time   ■ Part-time</a:t>
-            </a:r>
-          </a:p>
-        </p:txBody>
-      </p:sp>
-      <p:sp>
-        <p:nvSpPr>
-          <p:cNvPr id="4" name="Rectangle 3"/>
+              <a:t>Today</a:t>
+            </a:r>
+          </a:p>
+          <a:p>
+            <a:pPr algn="l">
+              <a:spcBef>
+                <a:spcPts val="0"/>
+              </a:spcBef>
+              <a:spcAft>
+                <a:spcPts val="800"/>
+              </a:spcAft>
+            </a:pPr>
+            <a:r>
+              <a:rPr sz="900" b="0" i="0">
+                <a:solidFill>
+                  <a:srgbClr val="000000"/>
+                </a:solidFill>
+                <a:latin typeface="Arial"/>
+              </a:rPr>
+              <a:t>PDFs reviewed by hand. Look-alike names treated as confirmed. Missing papers waved through.</a:t>
+            </a:r>
+          </a:p>
+          <a:p>
+            <a:pPr algn="l">
+              <a:spcBef>
+                <a:spcPts val="0"/>
+              </a:spcBef>
+              <a:spcAft>
+                <a:spcPts val="200"/>
+              </a:spcAft>
+            </a:pPr>
+            <a:r>
+              <a:rPr sz="900" b="1" i="0">
+                <a:solidFill>
+                  <a:srgbClr val="E9631D"/>
+                </a:solidFill>
+                <a:latin typeface="Arial"/>
+              </a:rPr>
+              <a:t>Pain</a:t>
+            </a:r>
+          </a:p>
+          <a:p>
+            <a:pPr algn="l">
+              <a:spcBef>
+                <a:spcPts val="0"/>
+              </a:spcBef>
+              <a:spcAft>
+                <a:spcPts val="0"/>
+              </a:spcAft>
+            </a:pPr>
+            <a:r>
+              <a:rPr sz="900" b="0" i="0">
+                <a:solidFill>
+                  <a:srgbClr val="000000"/>
+                </a:solidFill>
+                <a:latin typeface="Arial"/>
+              </a:rPr>
+              <a:t>Hours per file · weak audit trail · volume rising, headcount cannot keep up</a:t>
+            </a:r>
+          </a:p>
+        </p:txBody>
+      </p:sp>
+      <p:sp>
+        <p:nvSpPr>
+          <p:cNvPr id="5" name="Rectangle 4"/>
           <p:cNvSpPr/>
           <p:nvPr/>
         </p:nvSpPr>
         <p:spPr>
           <a:xfrm>
-            <a:off x="320040" y="1545336"/>
-            <a:ext cx="3777386" cy="2331720"/>
+            <a:off x="3264408" y="1115568"/>
+            <a:ext cx="5662879" cy="2788920"/>
           </a:xfrm>
           <a:prstGeom prst="rect">
             <a:avLst/>
@@ -3288,31 +3442,90 @@
           </a:fontRef>
         </p:style>
         <p:txBody>
-          <a:bodyPr rtlCol="0" anchor="t" wrap="square" lIns="73152" rIns="73152" tIns="54864" bIns="54864">
-            <a:noAutofit/>
-          </a:bodyPr>
-          <a:lstStyle/>
-          <a:p>
-            <a:pPr algn="l">
+          <a:bodyPr rtlCol="0" anchor="t" wrap="square" lIns="73152" rIns="73152"/>
+          <a:lstStyle/>
+          <a:p>
+            <a:pPr algn="ctr">
               <a:spcBef>
                 <a:spcPts val="0"/>
               </a:spcBef>
               <a:spcAft>
-                <a:spcPts val="500"/>
+                <a:spcPts val="200"/>
               </a:spcAft>
             </a:pPr>
             <a:r>
-              <a:rPr sz="1100" b="1" i="0">
-                <a:solidFill>
-                  <a:srgbClr val="000000"/>
+              <a:rPr sz="1200" b="1" i="0">
+                <a:solidFill>
+                  <a:srgbClr val="0B1F33"/>
                 </a:solidFill>
                 <a:latin typeface="Arial"/>
               </a:rPr>
-              <a:t>1. Problem</a:t>
-            </a:r>
-          </a:p>
-          <a:p>
-            <a:pPr algn="l">
+              <a:t>2. Solution — how TradePulse works</a:t>
+            </a:r>
+          </a:p>
+          <a:p>
+            <a:pPr algn="ctr">
+              <a:spcBef>
+                <a:spcPts val="0"/>
+              </a:spcBef>
+              <a:spcAft>
+                <a:spcPts val="0"/>
+              </a:spcAft>
+            </a:pPr>
+            <a:r>
+              <a:rPr sz="850" b="0" i="0">
+                <a:solidFill>
+                  <a:srgbClr val="000000"/>
+                </a:solidFill>
+                <a:latin typeface="Arial"/>
+              </a:rPr>
+              <a:t>Review desk for officers — we prepare the file; humans still decide</a:t>
+            </a:r>
+          </a:p>
+        </p:txBody>
+      </p:sp>
+      <p:sp>
+        <p:nvSpPr>
+          <p:cNvPr id="6" name="Rectangle 5"/>
+          <p:cNvSpPr/>
+          <p:nvPr/>
+        </p:nvSpPr>
+        <p:spPr>
+          <a:xfrm>
+            <a:off x="3370935" y="1892808"/>
+            <a:ext cx="1170432" cy="868680"/>
+          </a:xfrm>
+          <a:prstGeom prst="rect">
+            <a:avLst/>
+          </a:prstGeom>
+          <a:solidFill>
+            <a:srgbClr val="F4F7FA"/>
+          </a:solidFill>
+          <a:ln w="12700">
+            <a:solidFill>
+              <a:srgbClr val="0B1F33"/>
+            </a:solidFill>
+          </a:ln>
+        </p:spPr>
+        <p:style>
+          <a:lnRef idx="1">
+            <a:schemeClr val="accent1"/>
+          </a:lnRef>
+          <a:fillRef idx="3">
+            <a:schemeClr val="accent1"/>
+          </a:fillRef>
+          <a:effectRef idx="2">
+            <a:schemeClr val="accent1"/>
+          </a:effectRef>
+          <a:fontRef idx="minor">
+            <a:schemeClr val="lt1"/>
+          </a:fontRef>
+        </p:style>
+        <p:txBody>
+          <a:bodyPr rtlCol="0" anchor="ctr" wrap="square" lIns="73152" rIns="73152"/>
+          <a:lstStyle/>
+          <a:p>
+            <a:pPr algn="ctr">
               <a:spcBef>
                 <a:spcPts val="0"/>
               </a:spcBef>
@@ -3321,17 +3534,121 @@
               </a:spcAft>
             </a:pPr>
             <a:r>
-              <a:rPr sz="850" b="0" i="0">
-                <a:solidFill>
-                  <a:srgbClr val="000000"/>
+              <a:rPr sz="1000" b="1" i="0">
+                <a:solidFill>
+                  <a:srgbClr val="0B1F33"/>
                 </a:solidFill>
                 <a:latin typeface="Arial"/>
               </a:rPr>
-              <a:t>• Who: Trade officers at banks and GIFT City IBUs — first buyer is Head of Trade Finance Ops</a:t>
-            </a:r>
-          </a:p>
-          <a:p>
-            <a:pPr algn="l">
+              <a:t>Papers in</a:t>
+            </a:r>
+          </a:p>
+          <a:p>
+            <a:pPr algn="ctr">
+              <a:spcBef>
+                <a:spcPts val="0"/>
+              </a:spcBef>
+              <a:spcAft>
+                <a:spcPts val="0"/>
+              </a:spcAft>
+            </a:pPr>
+            <a:r>
+              <a:rPr sz="800" b="0" i="0">
+                <a:solidFill>
+                  <a:srgbClr val="000000"/>
+                </a:solidFill>
+                <a:latin typeface="Arial"/>
+              </a:rPr>
+              <a:t>Invoice + shipping docs</a:t>
+            </a:r>
+          </a:p>
+        </p:txBody>
+      </p:sp>
+      <p:sp>
+        <p:nvSpPr>
+          <p:cNvPr id="7" name="Right Arrow 6"/>
+          <p:cNvSpPr/>
+          <p:nvPr/>
+        </p:nvSpPr>
+        <p:spPr>
+          <a:xfrm>
+            <a:off x="4559655" y="2226564"/>
+            <a:ext cx="219456" cy="201168"/>
+          </a:xfrm>
+          <a:prstGeom prst="rightArrow">
+            <a:avLst/>
+          </a:prstGeom>
+          <a:solidFill>
+            <a:srgbClr val="E9631D"/>
+          </a:solidFill>
+          <a:ln>
+            <a:noFill/>
+          </a:ln>
+        </p:spPr>
+        <p:style>
+          <a:lnRef idx="1">
+            <a:schemeClr val="accent1"/>
+          </a:lnRef>
+          <a:fillRef idx="3">
+            <a:schemeClr val="accent1"/>
+          </a:fillRef>
+          <a:effectRef idx="2">
+            <a:schemeClr val="accent1"/>
+          </a:effectRef>
+          <a:fontRef idx="minor">
+            <a:schemeClr val="lt1"/>
+          </a:fontRef>
+        </p:style>
+        <p:txBody>
+          <a:bodyPr rtlCol="0" anchor="ctr"/>
+          <a:lstStyle/>
+          <a:p>
+            <a:pPr algn="ctr"/>
+          </a:p>
+        </p:txBody>
+      </p:sp>
+      <p:sp>
+        <p:nvSpPr>
+          <p:cNvPr id="8" name="Rectangle 7"/>
+          <p:cNvSpPr/>
+          <p:nvPr/>
+        </p:nvSpPr>
+        <p:spPr>
+          <a:xfrm>
+            <a:off x="4797399" y="1892808"/>
+            <a:ext cx="1170432" cy="868680"/>
+          </a:xfrm>
+          <a:prstGeom prst="rect">
+            <a:avLst/>
+          </a:prstGeom>
+          <a:solidFill>
+            <a:srgbClr val="F4F7FA"/>
+          </a:solidFill>
+          <a:ln w="12700">
+            <a:solidFill>
+              <a:srgbClr val="0B1F33"/>
+            </a:solidFill>
+          </a:ln>
+        </p:spPr>
+        <p:style>
+          <a:lnRef idx="1">
+            <a:schemeClr val="accent1"/>
+          </a:lnRef>
+          <a:fillRef idx="3">
+            <a:schemeClr val="accent1"/>
+          </a:fillRef>
+          <a:effectRef idx="2">
+            <a:schemeClr val="accent1"/>
+          </a:effectRef>
+          <a:fontRef idx="minor">
+            <a:schemeClr val="lt1"/>
+          </a:fontRef>
+        </p:style>
+        <p:txBody>
+          <a:bodyPr rtlCol="0" anchor="ctr" wrap="square" lIns="73152" rIns="73152"/>
+          <a:lstStyle/>
+          <a:p>
+            <a:pPr algn="ctr">
               <a:spcBef>
                 <a:spcPts val="0"/>
               </a:spcBef>
@@ -3340,17 +3657,17 @@
               </a:spcAft>
             </a:pPr>
             <a:r>
-              <a:rPr sz="850" b="0" i="0">
-                <a:solidFill>
-                  <a:srgbClr val="000000"/>
+              <a:rPr sz="1000" b="1" i="0">
+                <a:solidFill>
+                  <a:srgbClr val="0B1F33"/>
                 </a:solidFill>
                 <a:latin typeface="Arial"/>
               </a:rPr>
-              <a:t>• Today: Staff still grind through invoice + shipping PDFs by hand; a name that only looks alike gets treated as “confirmed”; missing papers get waved through</a:t>
-            </a:r>
-          </a:p>
-          <a:p>
-            <a:pPr algn="l">
+              <a:t>Read &amp; check</a:t>
+            </a:r>
+          </a:p>
+          <a:p>
+            <a:pPr algn="ctr">
               <a:spcBef>
                 <a:spcPts val="0"/>
               </a:spcBef>
@@ -3359,27 +3676,513 @@
               </a:spcAft>
             </a:pPr>
             <a:r>
-              <a:rPr sz="850" b="0" i="0">
+              <a:rPr sz="800" b="0" i="0">
                 <a:solidFill>
                   <a:srgbClr val="000000"/>
                 </a:solidFill>
                 <a:latin typeface="Arial"/>
               </a:rPr>
-              <a:t>• Pain: Hours per file; risky audit trail; queues explode as cross-border / IFSC volume grows — ops cannot scale with more headcount alone</a:t>
-            </a:r>
-          </a:p>
-        </p:txBody>
-      </p:sp>
-      <p:sp>
-        <p:nvSpPr>
-          <p:cNvPr id="5" name="Rectangle 4"/>
+              <a:t>Pull facts, double-check</a:t>
+            </a:r>
+          </a:p>
+        </p:txBody>
+      </p:sp>
+      <p:sp>
+        <p:nvSpPr>
+          <p:cNvPr id="9" name="Right Arrow 8"/>
           <p:cNvSpPr/>
           <p:nvPr/>
         </p:nvSpPr>
         <p:spPr>
           <a:xfrm>
-            <a:off x="4207154" y="1545336"/>
-            <a:ext cx="3777386" cy="2331720"/>
+            <a:off x="5986119" y="2226564"/>
+            <a:ext cx="219456" cy="201168"/>
+          </a:xfrm>
+          <a:prstGeom prst="rightArrow">
+            <a:avLst/>
+          </a:prstGeom>
+          <a:solidFill>
+            <a:srgbClr val="E9631D"/>
+          </a:solidFill>
+          <a:ln>
+            <a:noFill/>
+          </a:ln>
+        </p:spPr>
+        <p:style>
+          <a:lnRef idx="1">
+            <a:schemeClr val="accent1"/>
+          </a:lnRef>
+          <a:fillRef idx="3">
+            <a:schemeClr val="accent1"/>
+          </a:fillRef>
+          <a:effectRef idx="2">
+            <a:schemeClr val="accent1"/>
+          </a:effectRef>
+          <a:fontRef idx="minor">
+            <a:schemeClr val="lt1"/>
+          </a:fontRef>
+        </p:style>
+        <p:txBody>
+          <a:bodyPr rtlCol="0" anchor="ctr"/>
+          <a:lstStyle/>
+          <a:p>
+            <a:pPr algn="ctr"/>
+          </a:p>
+        </p:txBody>
+      </p:sp>
+      <p:sp>
+        <p:nvSpPr>
+          <p:cNvPr id="10" name="Rectangle 9"/>
+          <p:cNvSpPr/>
+          <p:nvPr/>
+        </p:nvSpPr>
+        <p:spPr>
+          <a:xfrm>
+            <a:off x="6223863" y="1892808"/>
+            <a:ext cx="1170432" cy="868680"/>
+          </a:xfrm>
+          <a:prstGeom prst="rect">
+            <a:avLst/>
+          </a:prstGeom>
+          <a:solidFill>
+            <a:srgbClr val="F4F7FA"/>
+          </a:solidFill>
+          <a:ln w="12700">
+            <a:solidFill>
+              <a:srgbClr val="0B1F33"/>
+            </a:solidFill>
+          </a:ln>
+        </p:spPr>
+        <p:style>
+          <a:lnRef idx="1">
+            <a:schemeClr val="accent1"/>
+          </a:lnRef>
+          <a:fillRef idx="3">
+            <a:schemeClr val="accent1"/>
+          </a:fillRef>
+          <a:effectRef idx="2">
+            <a:schemeClr val="accent1"/>
+          </a:effectRef>
+          <a:fontRef idx="minor">
+            <a:schemeClr val="lt1"/>
+          </a:fontRef>
+        </p:style>
+        <p:txBody>
+          <a:bodyPr rtlCol="0" anchor="ctr" wrap="square" lIns="73152" rIns="73152"/>
+          <a:lstStyle/>
+          <a:p>
+            <a:pPr algn="ctr">
+              <a:spcBef>
+                <a:spcPts val="0"/>
+              </a:spcBef>
+              <a:spcAft>
+                <a:spcPts val="300"/>
+              </a:spcAft>
+            </a:pPr>
+            <a:r>
+              <a:rPr sz="1000" b="1" i="0">
+                <a:solidFill>
+                  <a:srgbClr val="0B1F33"/>
+                </a:solidFill>
+                <a:latin typeface="Arial"/>
+              </a:rPr>
+              <a:t>Flag gaps</a:t>
+            </a:r>
+          </a:p>
+          <a:p>
+            <a:pPr algn="ctr">
+              <a:spcBef>
+                <a:spcPts val="0"/>
+              </a:spcBef>
+              <a:spcAft>
+                <a:spcPts val="0"/>
+              </a:spcAft>
+            </a:pPr>
+            <a:r>
+              <a:rPr sz="800" b="0" i="0">
+                <a:solidFill>
+                  <a:srgbClr val="000000"/>
+                </a:solidFill>
+                <a:latin typeface="Arial"/>
+              </a:rPr>
+              <a:t>Conflicts stay visible</a:t>
+            </a:r>
+          </a:p>
+        </p:txBody>
+      </p:sp>
+      <p:sp>
+        <p:nvSpPr>
+          <p:cNvPr id="11" name="Right Arrow 10"/>
+          <p:cNvSpPr/>
+          <p:nvPr/>
+        </p:nvSpPr>
+        <p:spPr>
+          <a:xfrm>
+            <a:off x="7412583" y="2226564"/>
+            <a:ext cx="219456" cy="201168"/>
+          </a:xfrm>
+          <a:prstGeom prst="rightArrow">
+            <a:avLst/>
+          </a:prstGeom>
+          <a:solidFill>
+            <a:srgbClr val="E9631D"/>
+          </a:solidFill>
+          <a:ln>
+            <a:noFill/>
+          </a:ln>
+        </p:spPr>
+        <p:style>
+          <a:lnRef idx="1">
+            <a:schemeClr val="accent1"/>
+          </a:lnRef>
+          <a:fillRef idx="3">
+            <a:schemeClr val="accent1"/>
+          </a:fillRef>
+          <a:effectRef idx="2">
+            <a:schemeClr val="accent1"/>
+          </a:effectRef>
+          <a:fontRef idx="minor">
+            <a:schemeClr val="lt1"/>
+          </a:fontRef>
+        </p:style>
+        <p:txBody>
+          <a:bodyPr rtlCol="0" anchor="ctr"/>
+          <a:lstStyle/>
+          <a:p>
+            <a:pPr algn="ctr"/>
+          </a:p>
+        </p:txBody>
+      </p:sp>
+      <p:sp>
+        <p:nvSpPr>
+          <p:cNvPr id="12" name="Rectangle 11"/>
+          <p:cNvSpPr/>
+          <p:nvPr/>
+        </p:nvSpPr>
+        <p:spPr>
+          <a:xfrm>
+            <a:off x="7650327" y="1892808"/>
+            <a:ext cx="1170432" cy="868680"/>
+          </a:xfrm>
+          <a:prstGeom prst="rect">
+            <a:avLst/>
+          </a:prstGeom>
+          <a:solidFill>
+            <a:srgbClr val="E9631D"/>
+          </a:solidFill>
+          <a:ln w="12700">
+            <a:solidFill>
+              <a:srgbClr val="0B1F33"/>
+            </a:solidFill>
+          </a:ln>
+        </p:spPr>
+        <p:style>
+          <a:lnRef idx="1">
+            <a:schemeClr val="accent1"/>
+          </a:lnRef>
+          <a:fillRef idx="3">
+            <a:schemeClr val="accent1"/>
+          </a:fillRef>
+          <a:effectRef idx="2">
+            <a:schemeClr val="accent1"/>
+          </a:effectRef>
+          <a:fontRef idx="minor">
+            <a:schemeClr val="lt1"/>
+          </a:fontRef>
+        </p:style>
+        <p:txBody>
+          <a:bodyPr rtlCol="0" anchor="ctr" wrap="square" lIns="73152" rIns="73152"/>
+          <a:lstStyle/>
+          <a:p>
+            <a:pPr algn="ctr">
+              <a:spcBef>
+                <a:spcPts val="0"/>
+              </a:spcBef>
+              <a:spcAft>
+                <a:spcPts val="300"/>
+              </a:spcAft>
+            </a:pPr>
+            <a:r>
+              <a:rPr sz="1000" b="1" i="0">
+                <a:solidFill>
+                  <a:srgbClr val="FFFFFF"/>
+                </a:solidFill>
+                <a:latin typeface="Arial"/>
+              </a:rPr>
+              <a:t>Officer decides</a:t>
+            </a:r>
+          </a:p>
+          <a:p>
+            <a:pPr algn="ctr">
+              <a:spcBef>
+                <a:spcPts val="0"/>
+              </a:spcBef>
+              <a:spcAft>
+                <a:spcPts val="0"/>
+              </a:spcAft>
+            </a:pPr>
+            <a:r>
+              <a:rPr sz="800" b="0" i="0">
+                <a:solidFill>
+                  <a:srgbClr val="FFFFFF"/>
+                </a:solidFill>
+                <a:latin typeface="Arial"/>
+              </a:rPr>
+              <a:t>Maker → Checker</a:t>
+            </a:r>
+          </a:p>
+        </p:txBody>
+      </p:sp>
+      <p:sp>
+        <p:nvSpPr>
+          <p:cNvPr id="13" name="Rectangle 12"/>
+          <p:cNvSpPr/>
+          <p:nvPr/>
+        </p:nvSpPr>
+        <p:spPr>
+          <a:xfrm>
+            <a:off x="3374136" y="2962656"/>
+            <a:ext cx="1765706" cy="502920"/>
+          </a:xfrm>
+          <a:prstGeom prst="rect">
+            <a:avLst/>
+          </a:prstGeom>
+          <a:solidFill>
+            <a:srgbClr val="FFFFFF"/>
+          </a:solidFill>
+          <a:ln w="12700">
+            <a:solidFill>
+              <a:srgbClr val="1D4E89"/>
+            </a:solidFill>
+          </a:ln>
+        </p:spPr>
+        <p:style>
+          <a:lnRef idx="1">
+            <a:schemeClr val="accent1"/>
+          </a:lnRef>
+          <a:fillRef idx="3">
+            <a:schemeClr val="accent1"/>
+          </a:fillRef>
+          <a:effectRef idx="2">
+            <a:schemeClr val="accent1"/>
+          </a:effectRef>
+          <a:fontRef idx="minor">
+            <a:schemeClr val="lt1"/>
+          </a:fontRef>
+        </p:style>
+        <p:txBody>
+          <a:bodyPr rtlCol="0" anchor="ctr" wrap="square" lIns="73152" rIns="73152"/>
+          <a:lstStyle/>
+          <a:p>
+            <a:pPr algn="ctr">
+              <a:spcBef>
+                <a:spcPts val="0"/>
+              </a:spcBef>
+              <a:spcAft>
+                <a:spcPts val="100"/>
+              </a:spcAft>
+            </a:pPr>
+            <a:r>
+              <a:rPr sz="900" b="1" i="0">
+                <a:solidFill>
+                  <a:srgbClr val="1D4E89"/>
+                </a:solidFill>
+                <a:latin typeface="Arial"/>
+              </a:rPr>
+              <a:t>No auto-approve</a:t>
+            </a:r>
+          </a:p>
+          <a:p>
+            <a:pPr algn="ctr">
+              <a:spcBef>
+                <a:spcPts val="0"/>
+              </a:spcBef>
+              <a:spcAft>
+                <a:spcPts val="0"/>
+              </a:spcAft>
+            </a:pPr>
+            <a:r>
+              <a:rPr sz="750" b="0" i="0">
+                <a:solidFill>
+                  <a:srgbClr val="000000"/>
+                </a:solidFill>
+                <a:latin typeface="Arial"/>
+              </a:rPr>
+              <a:t>Officers stay in charge</a:t>
+            </a:r>
+          </a:p>
+        </p:txBody>
+      </p:sp>
+      <p:sp>
+        <p:nvSpPr>
+          <p:cNvPr id="14" name="Rectangle 13"/>
+          <p:cNvSpPr/>
+          <p:nvPr/>
+        </p:nvSpPr>
+        <p:spPr>
+          <a:xfrm>
+            <a:off x="5212994" y="2962656"/>
+            <a:ext cx="1765706" cy="502920"/>
+          </a:xfrm>
+          <a:prstGeom prst="rect">
+            <a:avLst/>
+          </a:prstGeom>
+          <a:solidFill>
+            <a:srgbClr val="FFFFFF"/>
+          </a:solidFill>
+          <a:ln w="12700">
+            <a:solidFill>
+              <a:srgbClr val="1D4E89"/>
+            </a:solidFill>
+          </a:ln>
+        </p:spPr>
+        <p:style>
+          <a:lnRef idx="1">
+            <a:schemeClr val="accent1"/>
+          </a:lnRef>
+          <a:fillRef idx="3">
+            <a:schemeClr val="accent1"/>
+          </a:fillRef>
+          <a:effectRef idx="2">
+            <a:schemeClr val="accent1"/>
+          </a:effectRef>
+          <a:fontRef idx="minor">
+            <a:schemeClr val="lt1"/>
+          </a:fontRef>
+        </p:style>
+        <p:txBody>
+          <a:bodyPr rtlCol="0" anchor="ctr" wrap="square" lIns="73152" rIns="73152"/>
+          <a:lstStyle/>
+          <a:p>
+            <a:pPr algn="ctr">
+              <a:spcBef>
+                <a:spcPts val="0"/>
+              </a:spcBef>
+              <a:spcAft>
+                <a:spcPts val="100"/>
+              </a:spcAft>
+            </a:pPr>
+            <a:r>
+              <a:rPr sz="900" b="1" i="0">
+                <a:solidFill>
+                  <a:srgbClr val="1D4E89"/>
+                </a:solidFill>
+                <a:latin typeface="Arial"/>
+              </a:rPr>
+              <a:t>No fake “all clear”</a:t>
+            </a:r>
+          </a:p>
+          <a:p>
+            <a:pPr algn="ctr">
+              <a:spcBef>
+                <a:spcPts val="0"/>
+              </a:spcBef>
+              <a:spcAft>
+                <a:spcPts val="0"/>
+              </a:spcAft>
+            </a:pPr>
+            <a:r>
+              <a:rPr sz="750" b="0" i="0">
+                <a:solidFill>
+                  <a:srgbClr val="000000"/>
+                </a:solidFill>
+                <a:latin typeface="Arial"/>
+              </a:rPr>
+              <a:t>Missing data stays missing</a:t>
+            </a:r>
+          </a:p>
+        </p:txBody>
+      </p:sp>
+      <p:sp>
+        <p:nvSpPr>
+          <p:cNvPr id="15" name="Rectangle 14"/>
+          <p:cNvSpPr/>
+          <p:nvPr/>
+        </p:nvSpPr>
+        <p:spPr>
+          <a:xfrm>
+            <a:off x="7051852" y="2962656"/>
+            <a:ext cx="1765706" cy="502920"/>
+          </a:xfrm>
+          <a:prstGeom prst="rect">
+            <a:avLst/>
+          </a:prstGeom>
+          <a:solidFill>
+            <a:srgbClr val="FFFFFF"/>
+          </a:solidFill>
+          <a:ln w="12700">
+            <a:solidFill>
+              <a:srgbClr val="1D4E89"/>
+            </a:solidFill>
+          </a:ln>
+        </p:spPr>
+        <p:style>
+          <a:lnRef idx="1">
+            <a:schemeClr val="accent1"/>
+          </a:lnRef>
+          <a:fillRef idx="3">
+            <a:schemeClr val="accent1"/>
+          </a:fillRef>
+          <a:effectRef idx="2">
+            <a:schemeClr val="accent1"/>
+          </a:effectRef>
+          <a:fontRef idx="minor">
+            <a:schemeClr val="lt1"/>
+          </a:fontRef>
+        </p:style>
+        <p:txBody>
+          <a:bodyPr rtlCol="0" anchor="ctr" wrap="square" lIns="73152" rIns="73152"/>
+          <a:lstStyle/>
+          <a:p>
+            <a:pPr algn="ctr">
+              <a:spcBef>
+                <a:spcPts val="0"/>
+              </a:spcBef>
+              <a:spcAft>
+                <a:spcPts val="100"/>
+              </a:spcAft>
+            </a:pPr>
+            <a:r>
+              <a:rPr sz="900" b="1" i="0">
+                <a:solidFill>
+                  <a:srgbClr val="1D4E89"/>
+                </a:solidFill>
+                <a:latin typeface="Arial"/>
+              </a:rPr>
+              <a:t>Audit-ready pack</a:t>
+            </a:r>
+          </a:p>
+          <a:p>
+            <a:pPr algn="ctr">
+              <a:spcBef>
+                <a:spcPts val="0"/>
+              </a:spcBef>
+              <a:spcAft>
+                <a:spcPts val="0"/>
+              </a:spcAft>
+            </a:pPr>
+            <a:r>
+              <a:rPr sz="750" b="0" i="0">
+                <a:solidFill>
+                  <a:srgbClr val="000000"/>
+                </a:solidFill>
+                <a:latin typeface="Arial"/>
+              </a:rPr>
+              <a:t>Download &amp; hand off</a:t>
+            </a:r>
+          </a:p>
+        </p:txBody>
+      </p:sp>
+      <p:sp>
+        <p:nvSpPr>
+          <p:cNvPr id="16" name="Rectangle 15"/>
+          <p:cNvSpPr/>
+          <p:nvPr/>
+        </p:nvSpPr>
+        <p:spPr>
+          <a:xfrm>
+            <a:off x="9018727" y="1115568"/>
+            <a:ext cx="2880360" cy="2788920"/>
           </a:xfrm>
           <a:prstGeom prst="rect">
             <a:avLst/>
@@ -3408,9 +4211,7 @@
           </a:fontRef>
         </p:style>
         <p:txBody>
-          <a:bodyPr rtlCol="0" anchor="t" wrap="square" lIns="73152" rIns="73152" tIns="54864" bIns="54864">
-            <a:noAutofit/>
-          </a:bodyPr>
+          <a:bodyPr rtlCol="0" anchor="t" wrap="square" lIns="73152" rIns="73152"/>
           <a:lstStyle/>
           <a:p>
             <a:pPr algn="l">
@@ -3418,17 +4219,17 @@
                 <a:spcPts val="0"/>
               </a:spcBef>
               <a:spcAft>
-                <a:spcPts val="500"/>
+                <a:spcPts val="800"/>
               </a:spcAft>
             </a:pPr>
             <a:r>
-              <a:rPr sz="1100" b="1" i="0">
-                <a:solidFill>
-                  <a:srgbClr val="000000"/>
+              <a:rPr sz="1200" b="1" i="0">
+                <a:solidFill>
+                  <a:srgbClr val="0B1F33"/>
                 </a:solidFill>
                 <a:latin typeface="Arial"/>
               </a:rPr>
-              <a:t>2. Solution</a:t>
+              <a:t>3. Validation</a:t>
             </a:r>
           </a:p>
           <a:p>
@@ -3437,17 +4238,17 @@
                 <a:spcPts val="0"/>
               </a:spcBef>
               <a:spcAft>
-                <a:spcPts val="300"/>
+                <a:spcPts val="200"/>
               </a:spcAft>
             </a:pPr>
             <a:r>
-              <a:rPr sz="850" b="0" i="0">
-                <a:solidFill>
-                  <a:srgbClr val="000000"/>
+              <a:rPr sz="900" b="1" i="0">
+                <a:solidFill>
+                  <a:srgbClr val="E9631D"/>
                 </a:solidFill>
                 <a:latin typeface="Arial"/>
               </a:rPr>
-              <a:t>• Building: TradePulse — a review desk that prepares the case file; humans still decide (we do not auto-approve)</a:t>
+              <a:t>Buyer</a:t>
             </a:r>
           </a:p>
           <a:p>
@@ -3456,17 +4257,17 @@
                 <a:spcPts val="0"/>
               </a:spcBef>
               <a:spcAft>
-                <a:spcPts val="300"/>
+                <a:spcPts val="800"/>
               </a:spcAft>
             </a:pPr>
             <a:r>
-              <a:rPr sz="850" b="0" i="0">
+              <a:rPr sz="900" b="0" i="0">
                 <a:solidFill>
                   <a:srgbClr val="000000"/>
                 </a:solidFill>
                 <a:latin typeface="Arial"/>
               </a:rPr>
-              <a:t>• Value: Pulls facts from documents, double-checks them, flags conflicts, and hands officers a clear pack for maker → checker</a:t>
+              <a:t>Head of Trade Finance Ops — GIFT IBU / bank trade desk</a:t>
             </a:r>
           </a:p>
           <a:p>
@@ -3475,17 +4276,17 @@
                 <a:spcPts val="0"/>
               </a:spcBef>
               <a:spcAft>
-                <a:spcPts val="300"/>
+                <a:spcPts val="200"/>
               </a:spcAft>
             </a:pPr>
             <a:r>
-              <a:rPr sz="850" b="0" i="0">
-                <a:solidFill>
-                  <a:srgbClr val="000000"/>
+              <a:rPr sz="900" b="1" i="0">
+                <a:solidFill>
+                  <a:srgbClr val="E9631D"/>
                 </a:solidFill>
                 <a:latin typeface="Arial"/>
               </a:rPr>
-              <a:t>• Different / why now: We refuse fake “all clear” when data is missing; GIFT trade desks need faster review without cutting corners</a:t>
+              <a:t>Insight</a:t>
             </a:r>
           </a:p>
           <a:p>
@@ -3494,31 +4295,69 @@
                 <a:spcPts val="0"/>
               </a:spcBef>
               <a:spcAft>
-                <a:spcPts val="0"/>
+                <a:spcPts val="800"/>
               </a:spcAft>
             </a:pPr>
             <a:r>
-              <a:rPr sz="850" b="0" i="0">
+              <a:rPr sz="900" b="0" i="0">
                 <a:solidFill>
                   <a:srgbClr val="000000"/>
                 </a:solidFill>
                 <a:latin typeface="Arial"/>
               </a:rPr>
-              <a:t>• Innovation: Built-in honesty rules — every gap stays visible; every finding keeps its source for audit</a:t>
-            </a:r>
-          </a:p>
-        </p:txBody>
-      </p:sp>
-      <p:sp>
-        <p:nvSpPr>
-          <p:cNvPr id="6" name="Rectangle 5"/>
+              <a:t>Banks review paperwork — not the physical container. A look-alike name is not proof.</a:t>
+            </a:r>
+          </a:p>
+          <a:p>
+            <a:pPr algn="l">
+              <a:spcBef>
+                <a:spcPts val="0"/>
+              </a:spcBef>
+              <a:spcAft>
+                <a:spcPts val="200"/>
+              </a:spcAft>
+            </a:pPr>
+            <a:r>
+              <a:rPr sz="900" b="1" i="0">
+                <a:solidFill>
+                  <a:srgbClr val="E9631D"/>
+                </a:solidFill>
+                <a:latin typeface="Arial"/>
+              </a:rPr>
+              <a:t>Evidence</a:t>
+            </a:r>
+          </a:p>
+          <a:p>
+            <a:pPr algn="l">
+              <a:spcBef>
+                <a:spcPts val="0"/>
+              </a:spcBef>
+              <a:spcAft>
+                <a:spcPts val="0"/>
+              </a:spcAft>
+            </a:pPr>
+            <a:r>
+              <a:rPr sz="900" b="0" i="0">
+                <a:solidFill>
+                  <a:srgbClr val="000000"/>
+                </a:solidFill>
+                <a:latin typeface="Arial"/>
+              </a:rPr>
+              <a:t>Live demo on AWS (Mumbai) — open a case, see mismatches, download the handoff pack</a:t>
+            </a:r>
+          </a:p>
+        </p:txBody>
+      </p:sp>
+      <p:sp>
+        <p:nvSpPr>
+          <p:cNvPr id="17" name="Rectangle 16"/>
           <p:cNvSpPr/>
           <p:nvPr/>
         </p:nvSpPr>
         <p:spPr>
           <a:xfrm>
-            <a:off x="8094268" y="1545336"/>
-            <a:ext cx="3777386" cy="2331720"/>
+            <a:off x="292608" y="3995928"/>
+            <a:ext cx="3807866" cy="1234440"/>
           </a:xfrm>
           <a:prstGeom prst="rect">
             <a:avLst/>
@@ -3547,9 +4386,7 @@
           </a:fontRef>
         </p:style>
         <p:txBody>
-          <a:bodyPr rtlCol="0" anchor="t" wrap="square" lIns="73152" rIns="73152" tIns="54864" bIns="54864">
-            <a:noAutofit/>
-          </a:bodyPr>
+          <a:bodyPr rtlCol="0" anchor="t" wrap="square" lIns="73152" rIns="73152"/>
           <a:lstStyle/>
           <a:p>
             <a:pPr algn="l">
@@ -3563,11 +4400,11 @@
             <a:r>
               <a:rPr sz="1100" b="1" i="0">
                 <a:solidFill>
-                  <a:srgbClr val="000000"/>
+                  <a:srgbClr val="0B1F33"/>
                 </a:solidFill>
                 <a:latin typeface="Arial"/>
               </a:rPr>
-              <a:t>3. Validation</a:t>
+              <a:t>4. Regulatory</a:t>
             </a:r>
           </a:p>
           <a:p>
@@ -3586,7 +4423,7 @@
                 </a:solidFill>
                 <a:latin typeface="Arial"/>
               </a:rPr>
-              <a:t>• Buyer locked: Head of Trade Finance Ops at a GIFT City IBU / bank trade desk (formal interview log expands after the hackathon)</a:t>
+              <a:t>IFSCA / GIFT + bank trade ops (RBI)</a:t>
             </a:r>
           </a:p>
           <a:p>
@@ -3605,7 +4442,7 @@
                 </a:solidFill>
                 <a:latin typeface="Arial"/>
               </a:rPr>
-              <a:t>• What we heard: Banks review the paperwork — they do not “see inside the container”; a look-alike name is not proof of who someone is</a:t>
+              <a:t>We never say “AI approved / cleared / sanctioned”</a:t>
             </a:r>
           </a:p>
           <a:p>
@@ -3624,21 +4461,21 @@
                 </a:solidFill>
                 <a:latin typeface="Arial"/>
               </a:rPr>
-              <a:t>• Evidence: Working live demo on AWS (Mumbai); officers can open a case, see mismatches, and download a handoff pack — demo data clearly labelled</a:t>
-            </a:r>
-          </a:p>
-        </p:txBody>
-      </p:sp>
-      <p:sp>
-        <p:nvSpPr>
-          <p:cNvPr id="7" name="Rectangle 6"/>
+              <a:t>Officers stay in the loop — always</a:t>
+            </a:r>
+          </a:p>
+        </p:txBody>
+      </p:sp>
+      <p:sp>
+        <p:nvSpPr>
+          <p:cNvPr id="18" name="Rectangle 17"/>
           <p:cNvSpPr/>
           <p:nvPr/>
         </p:nvSpPr>
         <p:spPr>
           <a:xfrm>
-            <a:off x="320040" y="3986784"/>
-            <a:ext cx="5720943" cy="1417320"/>
+            <a:off x="4191914" y="3995928"/>
+            <a:ext cx="3807866" cy="1234440"/>
           </a:xfrm>
           <a:prstGeom prst="rect">
             <a:avLst/>
@@ -3667,9 +4504,7 @@
           </a:fontRef>
         </p:style>
         <p:txBody>
-          <a:bodyPr rtlCol="0" anchor="t" wrap="square" lIns="73152" rIns="73152" tIns="54864" bIns="54864">
-            <a:noAutofit/>
-          </a:bodyPr>
+          <a:bodyPr rtlCol="0" anchor="t" wrap="square" lIns="73152" rIns="73152"/>
           <a:lstStyle/>
           <a:p>
             <a:pPr algn="l">
@@ -3683,11 +4518,11 @@
             <a:r>
               <a:rPr sz="1100" b="1" i="0">
                 <a:solidFill>
-                  <a:srgbClr val="000000"/>
+                  <a:srgbClr val="0B1F33"/>
                 </a:solidFill>
                 <a:latin typeface="Arial"/>
               </a:rPr>
-              <a:t>4. Regulatory Requirements (Domestic/IFSC)</a:t>
+              <a:t>5. Team</a:t>
             </a:r>
           </a:p>
           <a:p>
@@ -3706,7 +4541,7 @@
                 </a:solidFill>
                 <a:latin typeface="Arial"/>
               </a:rPr>
-              <a:t>• Focus: IFSCA / GIFT City trade desks; bank trade ops under RBI; company ID checks via official LEI records where available</a:t>
+              <a:t>Abhishek — platform   ·   Ansh — product</a:t>
             </a:r>
           </a:p>
           <a:p>
@@ -3715,7 +4550,7 @@
                 <a:spcPts val="0"/>
               </a:spcBef>
               <a:spcAft>
-                <a:spcPts val="0"/>
+                <a:spcPts val="300"/>
               </a:spcAft>
             </a:pPr>
             <a:r>
@@ -3725,31 +4560,50 @@
                 </a:solidFill>
                 <a:latin typeface="Arial"/>
               </a:rPr>
-              <a:t>• Risks we refuse: Saying “AI approved / cleared / sanctioned”; treating a similar name as the same person; hiding missing data as a pass — officers stay in the loop</a:t>
-            </a:r>
-          </a:p>
-        </p:txBody>
-      </p:sp>
-      <p:sp>
-        <p:nvSpPr>
-          <p:cNvPr id="8" name="Rectangle 7"/>
+              <a:t>Atharva — UI   ·   Shivansh — quality</a:t>
+            </a:r>
+          </a:p>
+          <a:p>
+            <a:pPr algn="l">
+              <a:spcBef>
+                <a:spcPts val="0"/>
+              </a:spcBef>
+              <a:spcAft>
+                <a:spcPts val="0"/>
+              </a:spcAft>
+            </a:pPr>
+            <a:r>
+              <a:rPr sz="850" b="1" i="0">
+                <a:solidFill>
+                  <a:srgbClr val="000000"/>
+                </a:solidFill>
+                <a:latin typeface="Arial"/>
+              </a:rPr>
+              <a:t>Win: live clickable demo for officers today</a:t>
+            </a:r>
+          </a:p>
+        </p:txBody>
+      </p:sp>
+      <p:sp>
+        <p:nvSpPr>
+          <p:cNvPr id="19" name="Rectangle 18"/>
           <p:cNvSpPr/>
           <p:nvPr/>
         </p:nvSpPr>
         <p:spPr>
           <a:xfrm>
-            <a:off x="6150711" y="3986784"/>
-            <a:ext cx="5720943" cy="1417320"/>
+            <a:off x="8091220" y="3995928"/>
+            <a:ext cx="3807866" cy="1234440"/>
           </a:xfrm>
           <a:prstGeom prst="rect">
             <a:avLst/>
           </a:prstGeom>
           <a:solidFill>
-            <a:srgbClr val="FFFFFF"/>
+            <a:srgbClr val="F4F7FA"/>
           </a:solidFill>
           <a:ln w="12700">
             <a:solidFill>
-              <a:srgbClr val="000000"/>
+              <a:srgbClr val="E9631D"/>
             </a:solidFill>
           </a:ln>
         </p:spPr>
@@ -3768,9 +4622,7 @@
           </a:fontRef>
         </p:style>
         <p:txBody>
-          <a:bodyPr rtlCol="0" anchor="t" wrap="square" lIns="73152" rIns="73152" tIns="54864" bIns="54864">
-            <a:noAutofit/>
-          </a:bodyPr>
+          <a:bodyPr rtlCol="0" anchor="t" wrap="square" lIns="73152" rIns="73152"/>
           <a:lstStyle/>
           <a:p>
             <a:pPr algn="l">
@@ -3784,127 +4636,7 @@
             <a:r>
               <a:rPr sz="1100" b="1" i="0">
                 <a:solidFill>
-                  <a:srgbClr val="000000"/>
-                </a:solidFill>
-                <a:latin typeface="Arial"/>
-              </a:rPr>
-              <a:t>5. Team-Market Fit</a:t>
-            </a:r>
-          </a:p>
-          <a:p>
-            <a:pPr algn="l">
-              <a:spcBef>
-                <a:spcPts val="0"/>
-              </a:spcBef>
-              <a:spcAft>
-                <a:spcPts val="300"/>
-              </a:spcAft>
-            </a:pPr>
-            <a:r>
-              <a:rPr sz="850" b="0" i="0">
-                <a:solidFill>
-                  <a:srgbClr val="000000"/>
-                </a:solidFill>
-                <a:latin typeface="Arial"/>
-              </a:rPr>
-              <a:t>• Roles: Abhishek — platform; Ansh — product desk; Atharva — UI; Shivansh — quality gate</a:t>
-            </a:r>
-          </a:p>
-          <a:p>
-            <a:pPr algn="l">
-              <a:spcBef>
-                <a:spcPts val="0"/>
-              </a:spcBef>
-              <a:spcAft>
-                <a:spcPts val="300"/>
-              </a:spcAft>
-            </a:pPr>
-            <a:r>
-              <a:rPr sz="850" b="0" i="0">
-                <a:solidFill>
-                  <a:srgbClr val="000000"/>
-                </a:solidFill>
-                <a:latin typeface="Arial"/>
-              </a:rPr>
-              <a:t>• Why us: Clear owners; we stop when rules conflict instead of inventing answers mid-demo</a:t>
-            </a:r>
-          </a:p>
-          <a:p>
-            <a:pPr algn="l">
-              <a:spcBef>
-                <a:spcPts val="0"/>
-              </a:spcBef>
-              <a:spcAft>
-                <a:spcPts val="0"/>
-              </a:spcAft>
-            </a:pPr>
-            <a:r>
-              <a:rPr sz="850" b="0" i="0">
-                <a:solidFill>
-                  <a:srgbClr val="000000"/>
-                </a:solidFill>
-                <a:latin typeface="Arial"/>
-              </a:rPr>
-              <a:t>• Biggest win: Live cloud demo officers can click today — review desk, sample cases, downloadable handoff pack</a:t>
-            </a:r>
-          </a:p>
-        </p:txBody>
-      </p:sp>
-      <p:sp>
-        <p:nvSpPr>
-          <p:cNvPr id="9" name="Rectangle 8"/>
-          <p:cNvSpPr/>
-          <p:nvPr/>
-        </p:nvSpPr>
-        <p:spPr>
-          <a:xfrm>
-            <a:off x="320040" y="5513832"/>
-            <a:ext cx="11551615" cy="960120"/>
-          </a:xfrm>
-          <a:prstGeom prst="rect">
-            <a:avLst/>
-          </a:prstGeom>
-          <a:solidFill>
-            <a:srgbClr val="FFFFFF"/>
-          </a:solidFill>
-          <a:ln w="12700">
-            <a:solidFill>
-              <a:srgbClr val="000000"/>
-            </a:solidFill>
-          </a:ln>
-        </p:spPr>
-        <p:style>
-          <a:lnRef idx="1">
-            <a:schemeClr val="accent1"/>
-          </a:lnRef>
-          <a:fillRef idx="3">
-            <a:schemeClr val="accent1"/>
-          </a:fillRef>
-          <a:effectRef idx="2">
-            <a:schemeClr val="accent1"/>
-          </a:effectRef>
-          <a:fontRef idx="minor">
-            <a:schemeClr val="lt1"/>
-          </a:fontRef>
-        </p:style>
-        <p:txBody>
-          <a:bodyPr rtlCol="0" anchor="t" wrap="square" lIns="73152" rIns="73152" tIns="54864" bIns="54864">
-            <a:noAutofit/>
-          </a:bodyPr>
-          <a:lstStyle/>
-          <a:p>
-            <a:pPr algn="ctr">
-              <a:spcBef>
-                <a:spcPts val="0"/>
-              </a:spcBef>
-              <a:spcAft>
-                <a:spcPts val="500"/>
-              </a:spcAft>
-            </a:pPr>
-            <a:r>
-              <a:rPr sz="1200" b="1" i="0">
-                <a:solidFill>
-                  <a:srgbClr val="000000"/>
+                  <a:srgbClr val="E9631D"/>
                 </a:solidFill>
                 <a:latin typeface="Arial"/>
               </a:rPr>
@@ -3927,21 +4659,21 @@
                 </a:solidFill>
                 <a:latin typeface="Arial"/>
               </a:rPr>
-              <a:t>• Join Young Builders for: intro to GIFT trade desks, mentors in ops + compliance, and a path from this prototype to a supervised bank pilot — for Head of Trade Finance Ops at a GIFT City IBU</a:t>
-            </a:r>
-          </a:p>
-        </p:txBody>
-      </p:sp>
-      <p:sp>
-        <p:nvSpPr>
-          <p:cNvPr id="10" name="TextBox 9"/>
+              <a:t>Desk intros + mentors + path to a supervised bank pilot for GIFT trade ops</a:t>
+            </a:r>
+          </a:p>
+        </p:txBody>
+      </p:sp>
+      <p:sp>
+        <p:nvSpPr>
+          <p:cNvPr id="20" name="TextBox 19"/>
           <p:cNvSpPr txBox="1"/>
           <p:nvPr/>
         </p:nvSpPr>
         <p:spPr>
           <a:xfrm>
-            <a:off x="320040" y="6510528"/>
-            <a:ext cx="11551615" cy="292608"/>
+            <a:off x="292608" y="6537960"/>
+            <a:ext cx="11606479" cy="256032"/>
           </a:xfrm>
           <a:prstGeom prst="rect">
             <a:avLst/>
@@ -3949,8 +4681,8 @@
           <a:noFill/>
         </p:spPr>
         <p:txBody>
-          <a:bodyPr wrap="square" lIns="73152" rIns="73152" tIns="54864" bIns="54864" anchor="t">
-            <a:noAutofit/>
+          <a:bodyPr wrap="square" lIns="73152" rIns="73152" anchor="t">
+            <a:spAutoFit/>
           </a:bodyPr>
           <a:lstStyle/>
           <a:p>
@@ -3969,7 +4701,7 @@
                 </a:solidFill>
                 <a:latin typeface="Arial"/>
               </a:rPr>
-              <a:t>This is a guide for the content of your slide. Structure, formatting, and design are left to your discretion. Use evidence &amp; metrics wherever possible. Avoid paragraphs.</a:t>
+              <a:t>Guide for content — structure &amp; design are yours. Prefer evidence &amp; metrics. Avoid paragraphs.</a:t>
             </a:r>
           </a:p>
         </p:txBody>

</xml_diff>

<commit_message>
docs: densify Young Builders slide with flowchart and less text
Keep template header/footer and box grid; add Docs→Check→Flag→Officer flow and proof chips.

Co-authored-by: Cursor <cursoragent@cursor.com>
</commit_message>
<xml_diff>
--- a/docs/reports/TradePulse_Young_Builders_Pitch_One_Slide.pptx
+++ b/docs/reports/TradePulse_Young_Builders_Pitch_One_Slide.pptx
@@ -3096,8 +3096,8 @@
         </p:nvSpPr>
         <p:spPr>
           <a:xfrm>
-            <a:off x="292608" y="73152"/>
-            <a:ext cx="11606479" cy="292608"/>
+            <a:off x="320040" y="109728"/>
+            <a:ext cx="11551615" cy="347472"/>
           </a:xfrm>
           <a:prstGeom prst="rect">
             <a:avLst/>
@@ -3106,7 +3106,7 @@
         </p:spPr>
         <p:txBody>
           <a:bodyPr wrap="square" lIns="73152" rIns="73152" anchor="t">
-            <a:spAutoFit/>
+            <a:noAutofit/>
           </a:bodyPr>
           <a:lstStyle/>
           <a:p>
@@ -3119,7 +3119,7 @@
               </a:spcAft>
             </a:pPr>
             <a:r>
-              <a:rPr sz="1500" b="1" i="0">
+              <a:rPr sz="1600" b="1" i="0">
                 <a:solidFill>
                   <a:srgbClr val="000000"/>
                 </a:solidFill>
@@ -3138,107 +3138,8 @@
         </p:nvSpPr>
         <p:spPr>
           <a:xfrm>
-            <a:off x="292608" y="365760"/>
-            <a:ext cx="11606479" cy="658368"/>
-          </a:xfrm>
-          <a:prstGeom prst="rect">
-            <a:avLst/>
-          </a:prstGeom>
-          <a:solidFill>
-            <a:srgbClr val="F4F7FA"/>
-          </a:solidFill>
-          <a:ln w="12700">
-            <a:solidFill>
-              <a:srgbClr val="0B1F33"/>
-            </a:solidFill>
-          </a:ln>
-        </p:spPr>
-        <p:style>
-          <a:lnRef idx="1">
-            <a:schemeClr val="accent1"/>
-          </a:lnRef>
-          <a:fillRef idx="3">
-            <a:schemeClr val="accent1"/>
-          </a:fillRef>
-          <a:effectRef idx="2">
-            <a:schemeClr val="accent1"/>
-          </a:effectRef>
-          <a:fontRef idx="minor">
-            <a:schemeClr val="lt1"/>
-          </a:fontRef>
-        </p:style>
-        <p:txBody>
-          <a:bodyPr rtlCol="0" anchor="t" wrap="square" lIns="73152" rIns="73152"/>
-          <a:lstStyle/>
-          <a:p>
-            <a:pPr algn="ctr">
-              <a:spcBef>
-                <a:spcPts val="0"/>
-              </a:spcBef>
-              <a:spcAft>
-                <a:spcPts val="300"/>
-              </a:spcAft>
-            </a:pPr>
-            <a:r>
-              <a:rPr sz="1100" b="1" i="0">
-                <a:solidFill>
-                  <a:srgbClr val="0B1F33"/>
-                </a:solidFill>
-                <a:latin typeface="Arial"/>
-              </a:rPr>
-              <a:t>Pitch Snapshot</a:t>
-            </a:r>
-          </a:p>
-          <a:p>
-            <a:pPr algn="ctr">
-              <a:spcBef>
-                <a:spcPts val="0"/>
-              </a:spcBef>
-              <a:spcAft>
-                <a:spcPts val="200"/>
-              </a:spcAft>
-            </a:pPr>
-            <a:r>
-              <a:rPr sz="900" b="0" i="0">
-                <a:solidFill>
-                  <a:srgbClr val="000000"/>
-                </a:solidFill>
-                <a:latin typeface="Arial"/>
-              </a:rPr>
-              <a:t>TradePulse  ·  Track 1 — Agentic AI  ·  Bank / GIFT trade officers review documents faster &amp; safer</a:t>
-            </a:r>
-          </a:p>
-          <a:p>
-            <a:pPr algn="ctr">
-              <a:spcBef>
-                <a:spcPts val="0"/>
-              </a:spcBef>
-              <a:spcAft>
-                <a:spcPts val="0"/>
-              </a:spcAft>
-            </a:pPr>
-            <a:r>
-              <a:rPr sz="850" b="0" i="0">
-                <a:solidFill>
-                  <a:srgbClr val="000000"/>
-                </a:solidFill>
-                <a:latin typeface="Arial"/>
-              </a:rPr>
-              <a:t>Stage: □ Idea   ■ Prototype   □ MVP   □ Pilot     |     Commitment: □ Full-time   ■ Part-time</a:t>
-            </a:r>
-          </a:p>
-        </p:txBody>
-      </p:sp>
-      <p:sp>
-        <p:nvSpPr>
-          <p:cNvPr id="4" name="Rectangle 3"/>
-          <p:cNvSpPr/>
-          <p:nvPr/>
-        </p:nvSpPr>
-        <p:spPr>
-          <a:xfrm>
-            <a:off x="292608" y="1115568"/>
-            <a:ext cx="2880360" cy="2788920"/>
+            <a:off x="320040" y="475488"/>
+            <a:ext cx="11551615" cy="868680"/>
           </a:xfrm>
           <a:prstGeom prst="rect">
             <a:avLst/>
@@ -3267,120 +3168,46 @@
           </a:fontRef>
         </p:style>
         <p:txBody>
-          <a:bodyPr rtlCol="0" anchor="t" wrap="square" lIns="73152" rIns="73152"/>
-          <a:lstStyle/>
+          <a:bodyPr rtlCol="0" anchor="t" wrap="square" lIns="73152" rIns="73152">
+            <a:noAutofit/>
+          </a:bodyPr>
+          <a:lstStyle/>
+          <a:p>
+            <a:pPr algn="ctr">
+              <a:spcBef>
+                <a:spcPts val="0"/>
+              </a:spcBef>
+              <a:spcAft>
+                <a:spcPts val="500"/>
+              </a:spcAft>
+            </a:pPr>
+            <a:r>
+              <a:rPr sz="1200" b="1" i="0">
+                <a:solidFill>
+                  <a:srgbClr val="000000"/>
+                </a:solidFill>
+                <a:latin typeface="Arial"/>
+              </a:rPr>
+              <a:t>Pitch Snapshot</a:t>
+            </a:r>
+          </a:p>
           <a:p>
             <a:pPr algn="l">
               <a:spcBef>
                 <a:spcPts val="0"/>
               </a:spcBef>
               <a:spcAft>
-                <a:spcPts val="800"/>
+                <a:spcPts val="300"/>
               </a:spcAft>
             </a:pPr>
             <a:r>
-              <a:rPr sz="1200" b="1" i="0">
-                <a:solidFill>
-                  <a:srgbClr val="0B1F33"/>
+              <a:rPr sz="900" b="0" i="0">
+                <a:solidFill>
+                  <a:srgbClr val="000000"/>
                 </a:solidFill>
                 <a:latin typeface="Arial"/>
               </a:rPr>
-              <a:t>1. Problem</a:t>
-            </a:r>
-          </a:p>
-          <a:p>
-            <a:pPr algn="l">
-              <a:spcBef>
-                <a:spcPts val="0"/>
-              </a:spcBef>
-              <a:spcAft>
-                <a:spcPts val="200"/>
-              </a:spcAft>
-            </a:pPr>
-            <a:r>
-              <a:rPr sz="900" b="1" i="0">
-                <a:solidFill>
-                  <a:srgbClr val="E9631D"/>
-                </a:solidFill>
-                <a:latin typeface="Arial"/>
-              </a:rPr>
-              <a:t>Who</a:t>
-            </a:r>
-          </a:p>
-          <a:p>
-            <a:pPr algn="l">
-              <a:spcBef>
-                <a:spcPts val="0"/>
-              </a:spcBef>
-              <a:spcAft>
-                <a:spcPts val="800"/>
-              </a:spcAft>
-            </a:pPr>
-            <a:r>
-              <a:rPr sz="900" b="0" i="0">
-                <a:solidFill>
-                  <a:srgbClr val="000000"/>
-                </a:solidFill>
-                <a:latin typeface="Arial"/>
-              </a:rPr>
-              <a:t>Head of Trade Finance Ops at a GIFT City IBU / bank desk</a:t>
-            </a:r>
-          </a:p>
-          <a:p>
-            <a:pPr algn="l">
-              <a:spcBef>
-                <a:spcPts val="0"/>
-              </a:spcBef>
-              <a:spcAft>
-                <a:spcPts val="200"/>
-              </a:spcAft>
-            </a:pPr>
-            <a:r>
-              <a:rPr sz="900" b="1" i="0">
-                <a:solidFill>
-                  <a:srgbClr val="E9631D"/>
-                </a:solidFill>
-                <a:latin typeface="Arial"/>
-              </a:rPr>
-              <a:t>Today</a:t>
-            </a:r>
-          </a:p>
-          <a:p>
-            <a:pPr algn="l">
-              <a:spcBef>
-                <a:spcPts val="0"/>
-              </a:spcBef>
-              <a:spcAft>
-                <a:spcPts val="800"/>
-              </a:spcAft>
-            </a:pPr>
-            <a:r>
-              <a:rPr sz="900" b="0" i="0">
-                <a:solidFill>
-                  <a:srgbClr val="000000"/>
-                </a:solidFill>
-                <a:latin typeface="Arial"/>
-              </a:rPr>
-              <a:t>PDFs reviewed by hand. Look-alike names treated as confirmed. Missing papers waved through.</a:t>
-            </a:r>
-          </a:p>
-          <a:p>
-            <a:pPr algn="l">
-              <a:spcBef>
-                <a:spcPts val="0"/>
-              </a:spcBef>
-              <a:spcAft>
-                <a:spcPts val="200"/>
-              </a:spcAft>
-            </a:pPr>
-            <a:r>
-              <a:rPr sz="900" b="1" i="0">
-                <a:solidFill>
-                  <a:srgbClr val="E9631D"/>
-                </a:solidFill>
-                <a:latin typeface="Arial"/>
-              </a:rPr>
-              <a:t>Pain</a:t>
+              <a:t>• Team: TradePulse  |  Track 1 — Agentic AI  |  Focus: Faster, safer trade-document review for bank / GIFT officers</a:t>
             </a:r>
           </a:p>
           <a:p>
@@ -3399,21 +3226,21 @@
                 </a:solidFill>
                 <a:latin typeface="Arial"/>
               </a:rPr>
-              <a:t>Hours per file · weak audit trail · volume rising, headcount cannot keep up</a:t>
-            </a:r>
-          </a:p>
-        </p:txBody>
-      </p:sp>
-      <p:sp>
-        <p:nvSpPr>
-          <p:cNvPr id="5" name="Rectangle 4"/>
+              <a:t>• Stage: □ Idea   ■ Prototype   □ MVP   □ Pilot     • Commitment: □ Full-time   ■ Part-time</a:t>
+            </a:r>
+          </a:p>
+        </p:txBody>
+      </p:sp>
+      <p:sp>
+        <p:nvSpPr>
+          <p:cNvPr id="4" name="Rectangle 3"/>
           <p:cNvSpPr/>
           <p:nvPr/>
         </p:nvSpPr>
         <p:spPr>
           <a:xfrm>
-            <a:off x="3264408" y="1115568"/>
-            <a:ext cx="5662879" cy="2788920"/>
+            <a:off x="320040" y="1453896"/>
+            <a:ext cx="3777386" cy="2423160"/>
           </a:xfrm>
           <a:prstGeom prst="rect">
             <a:avLst/>
@@ -3442,29 +3269,107 @@
           </a:fontRef>
         </p:style>
         <p:txBody>
-          <a:bodyPr rtlCol="0" anchor="t" wrap="square" lIns="73152" rIns="73152"/>
-          <a:lstStyle/>
-          <a:p>
-            <a:pPr algn="ctr">
+          <a:bodyPr rtlCol="0" anchor="t" wrap="square" lIns="73152" rIns="73152">
+            <a:noAutofit/>
+          </a:bodyPr>
+          <a:lstStyle/>
+          <a:p>
+            <a:pPr algn="l">
               <a:spcBef>
                 <a:spcPts val="0"/>
               </a:spcBef>
               <a:spcAft>
-                <a:spcPts val="200"/>
+                <a:spcPts val="600"/>
               </a:spcAft>
             </a:pPr>
             <a:r>
-              <a:rPr sz="1200" b="1" i="0">
-                <a:solidFill>
-                  <a:srgbClr val="0B1F33"/>
+              <a:rPr sz="1100" b="1" i="0">
+                <a:solidFill>
+                  <a:srgbClr val="000000"/>
                 </a:solidFill>
                 <a:latin typeface="Arial"/>
               </a:rPr>
-              <a:t>2. Solution — how TradePulse works</a:t>
-            </a:r>
-          </a:p>
-          <a:p>
-            <a:pPr algn="ctr">
+              <a:t>1. Problem</a:t>
+            </a:r>
+          </a:p>
+          <a:p>
+            <a:pPr algn="l">
+              <a:spcBef>
+                <a:spcPts val="0"/>
+              </a:spcBef>
+              <a:spcAft>
+                <a:spcPts val="400"/>
+              </a:spcAft>
+            </a:pPr>
+            <a:r>
+              <a:rPr sz="900" b="0" i="0">
+                <a:solidFill>
+                  <a:srgbClr val="000000"/>
+                </a:solidFill>
+                <a:latin typeface="Arial"/>
+              </a:rPr>
+              <a:t>• Who: Trade officers at banks &amp; GIFT City IBUs</a:t>
+            </a:r>
+          </a:p>
+          <a:p>
+            <a:pPr algn="l">
+              <a:spcBef>
+                <a:spcPts val="0"/>
+              </a:spcBef>
+              <a:spcAft>
+                <a:spcPts val="400"/>
+              </a:spcAft>
+            </a:pPr>
+            <a:r>
+              <a:rPr sz="900" b="0" i="0">
+                <a:solidFill>
+                  <a:srgbClr val="000000"/>
+                </a:solidFill>
+                <a:latin typeface="Arial"/>
+              </a:rPr>
+              <a:t>• Buyer: Head of Trade Finance Ops</a:t>
+            </a:r>
+          </a:p>
+          <a:p>
+            <a:pPr algn="l">
+              <a:spcBef>
+                <a:spcPts val="0"/>
+              </a:spcBef>
+              <a:spcAft>
+                <a:spcPts val="400"/>
+              </a:spcAft>
+            </a:pPr>
+            <a:r>
+              <a:rPr sz="900" b="0" i="0">
+                <a:solidFill>
+                  <a:srgbClr val="000000"/>
+                </a:solidFill>
+                <a:latin typeface="Arial"/>
+              </a:rPr>
+              <a:t>• Today: Hand-checking invoice + shipping PDFs</a:t>
+            </a:r>
+          </a:p>
+          <a:p>
+            <a:pPr algn="l">
+              <a:spcBef>
+                <a:spcPts val="0"/>
+              </a:spcBef>
+              <a:spcAft>
+                <a:spcPts val="400"/>
+              </a:spcAft>
+            </a:pPr>
+            <a:r>
+              <a:rPr sz="900" b="0" i="0">
+                <a:solidFill>
+                  <a:srgbClr val="000000"/>
+                </a:solidFill>
+                <a:latin typeface="Arial"/>
+              </a:rPr>
+              <a:t>• Trap: Look-alike names treated as “confirmed”</a:t>
+            </a:r>
+          </a:p>
+          <a:p>
+            <a:pPr algn="l">
               <a:spcBef>
                 <a:spcPts val="0"/>
               </a:spcBef>
@@ -3473,716 +3378,27 @@
               </a:spcAft>
             </a:pPr>
             <a:r>
-              <a:rPr sz="850" b="0" i="0">
+              <a:rPr sz="900" b="0" i="0">
                 <a:solidFill>
                   <a:srgbClr val="000000"/>
                 </a:solidFill>
                 <a:latin typeface="Arial"/>
               </a:rPr>
-              <a:t>Review desk for officers — we prepare the file; humans still decide</a:t>
-            </a:r>
-          </a:p>
-        </p:txBody>
-      </p:sp>
-      <p:sp>
-        <p:nvSpPr>
-          <p:cNvPr id="6" name="Rectangle 5"/>
+              <a:t>• Pain: Hours per file · weak audit trail · rising volume</a:t>
+            </a:r>
+          </a:p>
+        </p:txBody>
+      </p:sp>
+      <p:sp>
+        <p:nvSpPr>
+          <p:cNvPr id="5" name="Rectangle 4"/>
           <p:cNvSpPr/>
           <p:nvPr/>
         </p:nvSpPr>
         <p:spPr>
           <a:xfrm>
-            <a:off x="3370935" y="1892808"/>
-            <a:ext cx="1170432" cy="868680"/>
-          </a:xfrm>
-          <a:prstGeom prst="rect">
-            <a:avLst/>
-          </a:prstGeom>
-          <a:solidFill>
-            <a:srgbClr val="F4F7FA"/>
-          </a:solidFill>
-          <a:ln w="12700">
-            <a:solidFill>
-              <a:srgbClr val="0B1F33"/>
-            </a:solidFill>
-          </a:ln>
-        </p:spPr>
-        <p:style>
-          <a:lnRef idx="1">
-            <a:schemeClr val="accent1"/>
-          </a:lnRef>
-          <a:fillRef idx="3">
-            <a:schemeClr val="accent1"/>
-          </a:fillRef>
-          <a:effectRef idx="2">
-            <a:schemeClr val="accent1"/>
-          </a:effectRef>
-          <a:fontRef idx="minor">
-            <a:schemeClr val="lt1"/>
-          </a:fontRef>
-        </p:style>
-        <p:txBody>
-          <a:bodyPr rtlCol="0" anchor="ctr" wrap="square" lIns="73152" rIns="73152"/>
-          <a:lstStyle/>
-          <a:p>
-            <a:pPr algn="ctr">
-              <a:spcBef>
-                <a:spcPts val="0"/>
-              </a:spcBef>
-              <a:spcAft>
-                <a:spcPts val="300"/>
-              </a:spcAft>
-            </a:pPr>
-            <a:r>
-              <a:rPr sz="1000" b="1" i="0">
-                <a:solidFill>
-                  <a:srgbClr val="0B1F33"/>
-                </a:solidFill>
-                <a:latin typeface="Arial"/>
-              </a:rPr>
-              <a:t>Papers in</a:t>
-            </a:r>
-          </a:p>
-          <a:p>
-            <a:pPr algn="ctr">
-              <a:spcBef>
-                <a:spcPts val="0"/>
-              </a:spcBef>
-              <a:spcAft>
-                <a:spcPts val="0"/>
-              </a:spcAft>
-            </a:pPr>
-            <a:r>
-              <a:rPr sz="800" b="0" i="0">
-                <a:solidFill>
-                  <a:srgbClr val="000000"/>
-                </a:solidFill>
-                <a:latin typeface="Arial"/>
-              </a:rPr>
-              <a:t>Invoice + shipping docs</a:t>
-            </a:r>
-          </a:p>
-        </p:txBody>
-      </p:sp>
-      <p:sp>
-        <p:nvSpPr>
-          <p:cNvPr id="7" name="Right Arrow 6"/>
-          <p:cNvSpPr/>
-          <p:nvPr/>
-        </p:nvSpPr>
-        <p:spPr>
-          <a:xfrm>
-            <a:off x="4559655" y="2226564"/>
-            <a:ext cx="219456" cy="201168"/>
-          </a:xfrm>
-          <a:prstGeom prst="rightArrow">
-            <a:avLst/>
-          </a:prstGeom>
-          <a:solidFill>
-            <a:srgbClr val="E9631D"/>
-          </a:solidFill>
-          <a:ln>
-            <a:noFill/>
-          </a:ln>
-        </p:spPr>
-        <p:style>
-          <a:lnRef idx="1">
-            <a:schemeClr val="accent1"/>
-          </a:lnRef>
-          <a:fillRef idx="3">
-            <a:schemeClr val="accent1"/>
-          </a:fillRef>
-          <a:effectRef idx="2">
-            <a:schemeClr val="accent1"/>
-          </a:effectRef>
-          <a:fontRef idx="minor">
-            <a:schemeClr val="lt1"/>
-          </a:fontRef>
-        </p:style>
-        <p:txBody>
-          <a:bodyPr rtlCol="0" anchor="ctr"/>
-          <a:lstStyle/>
-          <a:p>
-            <a:pPr algn="ctr"/>
-          </a:p>
-        </p:txBody>
-      </p:sp>
-      <p:sp>
-        <p:nvSpPr>
-          <p:cNvPr id="8" name="Rectangle 7"/>
-          <p:cNvSpPr/>
-          <p:nvPr/>
-        </p:nvSpPr>
-        <p:spPr>
-          <a:xfrm>
-            <a:off x="4797399" y="1892808"/>
-            <a:ext cx="1170432" cy="868680"/>
-          </a:xfrm>
-          <a:prstGeom prst="rect">
-            <a:avLst/>
-          </a:prstGeom>
-          <a:solidFill>
-            <a:srgbClr val="F4F7FA"/>
-          </a:solidFill>
-          <a:ln w="12700">
-            <a:solidFill>
-              <a:srgbClr val="0B1F33"/>
-            </a:solidFill>
-          </a:ln>
-        </p:spPr>
-        <p:style>
-          <a:lnRef idx="1">
-            <a:schemeClr val="accent1"/>
-          </a:lnRef>
-          <a:fillRef idx="3">
-            <a:schemeClr val="accent1"/>
-          </a:fillRef>
-          <a:effectRef idx="2">
-            <a:schemeClr val="accent1"/>
-          </a:effectRef>
-          <a:fontRef idx="minor">
-            <a:schemeClr val="lt1"/>
-          </a:fontRef>
-        </p:style>
-        <p:txBody>
-          <a:bodyPr rtlCol="0" anchor="ctr" wrap="square" lIns="73152" rIns="73152"/>
-          <a:lstStyle/>
-          <a:p>
-            <a:pPr algn="ctr">
-              <a:spcBef>
-                <a:spcPts val="0"/>
-              </a:spcBef>
-              <a:spcAft>
-                <a:spcPts val="300"/>
-              </a:spcAft>
-            </a:pPr>
-            <a:r>
-              <a:rPr sz="1000" b="1" i="0">
-                <a:solidFill>
-                  <a:srgbClr val="0B1F33"/>
-                </a:solidFill>
-                <a:latin typeface="Arial"/>
-              </a:rPr>
-              <a:t>Read &amp; check</a:t>
-            </a:r>
-          </a:p>
-          <a:p>
-            <a:pPr algn="ctr">
-              <a:spcBef>
-                <a:spcPts val="0"/>
-              </a:spcBef>
-              <a:spcAft>
-                <a:spcPts val="0"/>
-              </a:spcAft>
-            </a:pPr>
-            <a:r>
-              <a:rPr sz="800" b="0" i="0">
-                <a:solidFill>
-                  <a:srgbClr val="000000"/>
-                </a:solidFill>
-                <a:latin typeface="Arial"/>
-              </a:rPr>
-              <a:t>Pull facts, double-check</a:t>
-            </a:r>
-          </a:p>
-        </p:txBody>
-      </p:sp>
-      <p:sp>
-        <p:nvSpPr>
-          <p:cNvPr id="9" name="Right Arrow 8"/>
-          <p:cNvSpPr/>
-          <p:nvPr/>
-        </p:nvSpPr>
-        <p:spPr>
-          <a:xfrm>
-            <a:off x="5986119" y="2226564"/>
-            <a:ext cx="219456" cy="201168"/>
-          </a:xfrm>
-          <a:prstGeom prst="rightArrow">
-            <a:avLst/>
-          </a:prstGeom>
-          <a:solidFill>
-            <a:srgbClr val="E9631D"/>
-          </a:solidFill>
-          <a:ln>
-            <a:noFill/>
-          </a:ln>
-        </p:spPr>
-        <p:style>
-          <a:lnRef idx="1">
-            <a:schemeClr val="accent1"/>
-          </a:lnRef>
-          <a:fillRef idx="3">
-            <a:schemeClr val="accent1"/>
-          </a:fillRef>
-          <a:effectRef idx="2">
-            <a:schemeClr val="accent1"/>
-          </a:effectRef>
-          <a:fontRef idx="minor">
-            <a:schemeClr val="lt1"/>
-          </a:fontRef>
-        </p:style>
-        <p:txBody>
-          <a:bodyPr rtlCol="0" anchor="ctr"/>
-          <a:lstStyle/>
-          <a:p>
-            <a:pPr algn="ctr"/>
-          </a:p>
-        </p:txBody>
-      </p:sp>
-      <p:sp>
-        <p:nvSpPr>
-          <p:cNvPr id="10" name="Rectangle 9"/>
-          <p:cNvSpPr/>
-          <p:nvPr/>
-        </p:nvSpPr>
-        <p:spPr>
-          <a:xfrm>
-            <a:off x="6223863" y="1892808"/>
-            <a:ext cx="1170432" cy="868680"/>
-          </a:xfrm>
-          <a:prstGeom prst="rect">
-            <a:avLst/>
-          </a:prstGeom>
-          <a:solidFill>
-            <a:srgbClr val="F4F7FA"/>
-          </a:solidFill>
-          <a:ln w="12700">
-            <a:solidFill>
-              <a:srgbClr val="0B1F33"/>
-            </a:solidFill>
-          </a:ln>
-        </p:spPr>
-        <p:style>
-          <a:lnRef idx="1">
-            <a:schemeClr val="accent1"/>
-          </a:lnRef>
-          <a:fillRef idx="3">
-            <a:schemeClr val="accent1"/>
-          </a:fillRef>
-          <a:effectRef idx="2">
-            <a:schemeClr val="accent1"/>
-          </a:effectRef>
-          <a:fontRef idx="minor">
-            <a:schemeClr val="lt1"/>
-          </a:fontRef>
-        </p:style>
-        <p:txBody>
-          <a:bodyPr rtlCol="0" anchor="ctr" wrap="square" lIns="73152" rIns="73152"/>
-          <a:lstStyle/>
-          <a:p>
-            <a:pPr algn="ctr">
-              <a:spcBef>
-                <a:spcPts val="0"/>
-              </a:spcBef>
-              <a:spcAft>
-                <a:spcPts val="300"/>
-              </a:spcAft>
-            </a:pPr>
-            <a:r>
-              <a:rPr sz="1000" b="1" i="0">
-                <a:solidFill>
-                  <a:srgbClr val="0B1F33"/>
-                </a:solidFill>
-                <a:latin typeface="Arial"/>
-              </a:rPr>
-              <a:t>Flag gaps</a:t>
-            </a:r>
-          </a:p>
-          <a:p>
-            <a:pPr algn="ctr">
-              <a:spcBef>
-                <a:spcPts val="0"/>
-              </a:spcBef>
-              <a:spcAft>
-                <a:spcPts val="0"/>
-              </a:spcAft>
-            </a:pPr>
-            <a:r>
-              <a:rPr sz="800" b="0" i="0">
-                <a:solidFill>
-                  <a:srgbClr val="000000"/>
-                </a:solidFill>
-                <a:latin typeface="Arial"/>
-              </a:rPr>
-              <a:t>Conflicts stay visible</a:t>
-            </a:r>
-          </a:p>
-        </p:txBody>
-      </p:sp>
-      <p:sp>
-        <p:nvSpPr>
-          <p:cNvPr id="11" name="Right Arrow 10"/>
-          <p:cNvSpPr/>
-          <p:nvPr/>
-        </p:nvSpPr>
-        <p:spPr>
-          <a:xfrm>
-            <a:off x="7412583" y="2226564"/>
-            <a:ext cx="219456" cy="201168"/>
-          </a:xfrm>
-          <a:prstGeom prst="rightArrow">
-            <a:avLst/>
-          </a:prstGeom>
-          <a:solidFill>
-            <a:srgbClr val="E9631D"/>
-          </a:solidFill>
-          <a:ln>
-            <a:noFill/>
-          </a:ln>
-        </p:spPr>
-        <p:style>
-          <a:lnRef idx="1">
-            <a:schemeClr val="accent1"/>
-          </a:lnRef>
-          <a:fillRef idx="3">
-            <a:schemeClr val="accent1"/>
-          </a:fillRef>
-          <a:effectRef idx="2">
-            <a:schemeClr val="accent1"/>
-          </a:effectRef>
-          <a:fontRef idx="minor">
-            <a:schemeClr val="lt1"/>
-          </a:fontRef>
-        </p:style>
-        <p:txBody>
-          <a:bodyPr rtlCol="0" anchor="ctr"/>
-          <a:lstStyle/>
-          <a:p>
-            <a:pPr algn="ctr"/>
-          </a:p>
-        </p:txBody>
-      </p:sp>
-      <p:sp>
-        <p:nvSpPr>
-          <p:cNvPr id="12" name="Rectangle 11"/>
-          <p:cNvSpPr/>
-          <p:nvPr/>
-        </p:nvSpPr>
-        <p:spPr>
-          <a:xfrm>
-            <a:off x="7650327" y="1892808"/>
-            <a:ext cx="1170432" cy="868680"/>
-          </a:xfrm>
-          <a:prstGeom prst="rect">
-            <a:avLst/>
-          </a:prstGeom>
-          <a:solidFill>
-            <a:srgbClr val="E9631D"/>
-          </a:solidFill>
-          <a:ln w="12700">
-            <a:solidFill>
-              <a:srgbClr val="0B1F33"/>
-            </a:solidFill>
-          </a:ln>
-        </p:spPr>
-        <p:style>
-          <a:lnRef idx="1">
-            <a:schemeClr val="accent1"/>
-          </a:lnRef>
-          <a:fillRef idx="3">
-            <a:schemeClr val="accent1"/>
-          </a:fillRef>
-          <a:effectRef idx="2">
-            <a:schemeClr val="accent1"/>
-          </a:effectRef>
-          <a:fontRef idx="minor">
-            <a:schemeClr val="lt1"/>
-          </a:fontRef>
-        </p:style>
-        <p:txBody>
-          <a:bodyPr rtlCol="0" anchor="ctr" wrap="square" lIns="73152" rIns="73152"/>
-          <a:lstStyle/>
-          <a:p>
-            <a:pPr algn="ctr">
-              <a:spcBef>
-                <a:spcPts val="0"/>
-              </a:spcBef>
-              <a:spcAft>
-                <a:spcPts val="300"/>
-              </a:spcAft>
-            </a:pPr>
-            <a:r>
-              <a:rPr sz="1000" b="1" i="0">
-                <a:solidFill>
-                  <a:srgbClr val="FFFFFF"/>
-                </a:solidFill>
-                <a:latin typeface="Arial"/>
-              </a:rPr>
-              <a:t>Officer decides</a:t>
-            </a:r>
-          </a:p>
-          <a:p>
-            <a:pPr algn="ctr">
-              <a:spcBef>
-                <a:spcPts val="0"/>
-              </a:spcBef>
-              <a:spcAft>
-                <a:spcPts val="0"/>
-              </a:spcAft>
-            </a:pPr>
-            <a:r>
-              <a:rPr sz="800" b="0" i="0">
-                <a:solidFill>
-                  <a:srgbClr val="FFFFFF"/>
-                </a:solidFill>
-                <a:latin typeface="Arial"/>
-              </a:rPr>
-              <a:t>Maker → Checker</a:t>
-            </a:r>
-          </a:p>
-        </p:txBody>
-      </p:sp>
-      <p:sp>
-        <p:nvSpPr>
-          <p:cNvPr id="13" name="Rectangle 12"/>
-          <p:cNvSpPr/>
-          <p:nvPr/>
-        </p:nvSpPr>
-        <p:spPr>
-          <a:xfrm>
-            <a:off x="3374136" y="2962656"/>
-            <a:ext cx="1765706" cy="502920"/>
-          </a:xfrm>
-          <a:prstGeom prst="rect">
-            <a:avLst/>
-          </a:prstGeom>
-          <a:solidFill>
-            <a:srgbClr val="FFFFFF"/>
-          </a:solidFill>
-          <a:ln w="12700">
-            <a:solidFill>
-              <a:srgbClr val="1D4E89"/>
-            </a:solidFill>
-          </a:ln>
-        </p:spPr>
-        <p:style>
-          <a:lnRef idx="1">
-            <a:schemeClr val="accent1"/>
-          </a:lnRef>
-          <a:fillRef idx="3">
-            <a:schemeClr val="accent1"/>
-          </a:fillRef>
-          <a:effectRef idx="2">
-            <a:schemeClr val="accent1"/>
-          </a:effectRef>
-          <a:fontRef idx="minor">
-            <a:schemeClr val="lt1"/>
-          </a:fontRef>
-        </p:style>
-        <p:txBody>
-          <a:bodyPr rtlCol="0" anchor="ctr" wrap="square" lIns="73152" rIns="73152"/>
-          <a:lstStyle/>
-          <a:p>
-            <a:pPr algn="ctr">
-              <a:spcBef>
-                <a:spcPts val="0"/>
-              </a:spcBef>
-              <a:spcAft>
-                <a:spcPts val="100"/>
-              </a:spcAft>
-            </a:pPr>
-            <a:r>
-              <a:rPr sz="900" b="1" i="0">
-                <a:solidFill>
-                  <a:srgbClr val="1D4E89"/>
-                </a:solidFill>
-                <a:latin typeface="Arial"/>
-              </a:rPr>
-              <a:t>No auto-approve</a:t>
-            </a:r>
-          </a:p>
-          <a:p>
-            <a:pPr algn="ctr">
-              <a:spcBef>
-                <a:spcPts val="0"/>
-              </a:spcBef>
-              <a:spcAft>
-                <a:spcPts val="0"/>
-              </a:spcAft>
-            </a:pPr>
-            <a:r>
-              <a:rPr sz="750" b="0" i="0">
-                <a:solidFill>
-                  <a:srgbClr val="000000"/>
-                </a:solidFill>
-                <a:latin typeface="Arial"/>
-              </a:rPr>
-              <a:t>Officers stay in charge</a:t>
-            </a:r>
-          </a:p>
-        </p:txBody>
-      </p:sp>
-      <p:sp>
-        <p:nvSpPr>
-          <p:cNvPr id="14" name="Rectangle 13"/>
-          <p:cNvSpPr/>
-          <p:nvPr/>
-        </p:nvSpPr>
-        <p:spPr>
-          <a:xfrm>
-            <a:off x="5212994" y="2962656"/>
-            <a:ext cx="1765706" cy="502920"/>
-          </a:xfrm>
-          <a:prstGeom prst="rect">
-            <a:avLst/>
-          </a:prstGeom>
-          <a:solidFill>
-            <a:srgbClr val="FFFFFF"/>
-          </a:solidFill>
-          <a:ln w="12700">
-            <a:solidFill>
-              <a:srgbClr val="1D4E89"/>
-            </a:solidFill>
-          </a:ln>
-        </p:spPr>
-        <p:style>
-          <a:lnRef idx="1">
-            <a:schemeClr val="accent1"/>
-          </a:lnRef>
-          <a:fillRef idx="3">
-            <a:schemeClr val="accent1"/>
-          </a:fillRef>
-          <a:effectRef idx="2">
-            <a:schemeClr val="accent1"/>
-          </a:effectRef>
-          <a:fontRef idx="minor">
-            <a:schemeClr val="lt1"/>
-          </a:fontRef>
-        </p:style>
-        <p:txBody>
-          <a:bodyPr rtlCol="0" anchor="ctr" wrap="square" lIns="73152" rIns="73152"/>
-          <a:lstStyle/>
-          <a:p>
-            <a:pPr algn="ctr">
-              <a:spcBef>
-                <a:spcPts val="0"/>
-              </a:spcBef>
-              <a:spcAft>
-                <a:spcPts val="100"/>
-              </a:spcAft>
-            </a:pPr>
-            <a:r>
-              <a:rPr sz="900" b="1" i="0">
-                <a:solidFill>
-                  <a:srgbClr val="1D4E89"/>
-                </a:solidFill>
-                <a:latin typeface="Arial"/>
-              </a:rPr>
-              <a:t>No fake “all clear”</a:t>
-            </a:r>
-          </a:p>
-          <a:p>
-            <a:pPr algn="ctr">
-              <a:spcBef>
-                <a:spcPts val="0"/>
-              </a:spcBef>
-              <a:spcAft>
-                <a:spcPts val="0"/>
-              </a:spcAft>
-            </a:pPr>
-            <a:r>
-              <a:rPr sz="750" b="0" i="0">
-                <a:solidFill>
-                  <a:srgbClr val="000000"/>
-                </a:solidFill>
-                <a:latin typeface="Arial"/>
-              </a:rPr>
-              <a:t>Missing data stays missing</a:t>
-            </a:r>
-          </a:p>
-        </p:txBody>
-      </p:sp>
-      <p:sp>
-        <p:nvSpPr>
-          <p:cNvPr id="15" name="Rectangle 14"/>
-          <p:cNvSpPr/>
-          <p:nvPr/>
-        </p:nvSpPr>
-        <p:spPr>
-          <a:xfrm>
-            <a:off x="7051852" y="2962656"/>
-            <a:ext cx="1765706" cy="502920"/>
-          </a:xfrm>
-          <a:prstGeom prst="rect">
-            <a:avLst/>
-          </a:prstGeom>
-          <a:solidFill>
-            <a:srgbClr val="FFFFFF"/>
-          </a:solidFill>
-          <a:ln w="12700">
-            <a:solidFill>
-              <a:srgbClr val="1D4E89"/>
-            </a:solidFill>
-          </a:ln>
-        </p:spPr>
-        <p:style>
-          <a:lnRef idx="1">
-            <a:schemeClr val="accent1"/>
-          </a:lnRef>
-          <a:fillRef idx="3">
-            <a:schemeClr val="accent1"/>
-          </a:fillRef>
-          <a:effectRef idx="2">
-            <a:schemeClr val="accent1"/>
-          </a:effectRef>
-          <a:fontRef idx="minor">
-            <a:schemeClr val="lt1"/>
-          </a:fontRef>
-        </p:style>
-        <p:txBody>
-          <a:bodyPr rtlCol="0" anchor="ctr" wrap="square" lIns="73152" rIns="73152"/>
-          <a:lstStyle/>
-          <a:p>
-            <a:pPr algn="ctr">
-              <a:spcBef>
-                <a:spcPts val="0"/>
-              </a:spcBef>
-              <a:spcAft>
-                <a:spcPts val="100"/>
-              </a:spcAft>
-            </a:pPr>
-            <a:r>
-              <a:rPr sz="900" b="1" i="0">
-                <a:solidFill>
-                  <a:srgbClr val="1D4E89"/>
-                </a:solidFill>
-                <a:latin typeface="Arial"/>
-              </a:rPr>
-              <a:t>Audit-ready pack</a:t>
-            </a:r>
-          </a:p>
-          <a:p>
-            <a:pPr algn="ctr">
-              <a:spcBef>
-                <a:spcPts val="0"/>
-              </a:spcBef>
-              <a:spcAft>
-                <a:spcPts val="0"/>
-              </a:spcAft>
-            </a:pPr>
-            <a:r>
-              <a:rPr sz="750" b="0" i="0">
-                <a:solidFill>
-                  <a:srgbClr val="000000"/>
-                </a:solidFill>
-                <a:latin typeface="Arial"/>
-              </a:rPr>
-              <a:t>Download &amp; hand off</a:t>
-            </a:r>
-          </a:p>
-        </p:txBody>
-      </p:sp>
-      <p:sp>
-        <p:nvSpPr>
-          <p:cNvPr id="16" name="Rectangle 15"/>
-          <p:cNvSpPr/>
-          <p:nvPr/>
-        </p:nvSpPr>
-        <p:spPr>
-          <a:xfrm>
-            <a:off x="9018727" y="1115568"/>
-            <a:ext cx="2880360" cy="2788920"/>
+            <a:off x="4207154" y="1453896"/>
+            <a:ext cx="3777386" cy="2423160"/>
           </a:xfrm>
           <a:prstGeom prst="rect">
             <a:avLst/>
@@ -4211,7 +3427,9 @@
           </a:fontRef>
         </p:style>
         <p:txBody>
-          <a:bodyPr rtlCol="0" anchor="t" wrap="square" lIns="73152" rIns="73152"/>
+          <a:bodyPr rtlCol="0" anchor="t" wrap="square" lIns="73152" rIns="73152">
+            <a:noAutofit/>
+          </a:bodyPr>
           <a:lstStyle/>
           <a:p>
             <a:pPr algn="l">
@@ -4219,17 +3437,36 @@
                 <a:spcPts val="0"/>
               </a:spcBef>
               <a:spcAft>
-                <a:spcPts val="800"/>
+                <a:spcPts val="500"/>
               </a:spcAft>
             </a:pPr>
             <a:r>
-              <a:rPr sz="1200" b="1" i="0">
-                <a:solidFill>
-                  <a:srgbClr val="0B1F33"/>
+              <a:rPr sz="1100" b="1" i="0">
+                <a:solidFill>
+                  <a:srgbClr val="000000"/>
                 </a:solidFill>
                 <a:latin typeface="Arial"/>
               </a:rPr>
-              <a:t>3. Validation</a:t>
+              <a:t>2. Solution</a:t>
+            </a:r>
+          </a:p>
+          <a:p>
+            <a:pPr algn="l">
+              <a:spcBef>
+                <a:spcPts val="0"/>
+              </a:spcBef>
+              <a:spcAft>
+                <a:spcPts val="300"/>
+              </a:spcAft>
+            </a:pPr>
+            <a:r>
+              <a:rPr sz="900" b="0" i="0">
+                <a:solidFill>
+                  <a:srgbClr val="000000"/>
+                </a:solidFill>
+                <a:latin typeface="Arial"/>
+              </a:rPr>
+              <a:t>• TradePulse = review desk (not auto-approve)</a:t>
             </a:r>
           </a:p>
           <a:p>
@@ -4242,36 +3479,388 @@
               </a:spcAft>
             </a:pPr>
             <a:r>
-              <a:rPr sz="900" b="1" i="0">
-                <a:solidFill>
-                  <a:srgbClr val="E9631D"/>
+              <a:rPr sz="900" b="0" i="0">
+                <a:solidFill>
+                  <a:srgbClr val="000000"/>
                 </a:solidFill>
                 <a:latin typeface="Arial"/>
               </a:rPr>
-              <a:t>Buyer</a:t>
-            </a:r>
-          </a:p>
-          <a:p>
-            <a:pPr algn="l">
-              <a:spcBef>
-                <a:spcPts val="0"/>
-              </a:spcBef>
-              <a:spcAft>
-                <a:spcPts val="800"/>
-              </a:spcAft>
-            </a:pPr>
-            <a:r>
-              <a:rPr sz="900" b="0" i="0">
-                <a:solidFill>
-                  <a:srgbClr val="000000"/>
+              <a:t>• Missing data never becomes a fake “all clear”</a:t>
+            </a:r>
+          </a:p>
+        </p:txBody>
+      </p:sp>
+      <p:sp>
+        <p:nvSpPr>
+          <p:cNvPr id="6" name="Rounded Rectangle 5"/>
+          <p:cNvSpPr/>
+          <p:nvPr/>
+        </p:nvSpPr>
+        <p:spPr>
+          <a:xfrm>
+            <a:off x="4316882" y="2414016"/>
+            <a:ext cx="738606" cy="530352"/>
+          </a:xfrm>
+          <a:prstGeom prst="roundRect">
+            <a:avLst/>
+          </a:prstGeom>
+          <a:solidFill>
+            <a:srgbClr val="F1F5F9"/>
+          </a:solidFill>
+          <a:ln w="12700">
+            <a:solidFill>
+              <a:srgbClr val="0B1F33"/>
+            </a:solidFill>
+          </a:ln>
+        </p:spPr>
+        <p:style>
+          <a:lnRef idx="1">
+            <a:schemeClr val="accent1"/>
+          </a:lnRef>
+          <a:fillRef idx="3">
+            <a:schemeClr val="accent1"/>
+          </a:fillRef>
+          <a:effectRef idx="2">
+            <a:schemeClr val="accent1"/>
+          </a:effectRef>
+          <a:fontRef idx="minor">
+            <a:schemeClr val="lt1"/>
+          </a:fontRef>
+        </p:style>
+        <p:txBody>
+          <a:bodyPr rtlCol="0" anchor="ctr" wrap="square" lIns="36576" rIns="36576" tIns="36576" bIns="36576"/>
+          <a:lstStyle/>
+          <a:p>
+            <a:pPr algn="ctr"/>
+            <a:r>
+              <a:rPr sz="800" b="1" i="0">
+                <a:solidFill>
+                  <a:srgbClr val="0B1F33"/>
                 </a:solidFill>
                 <a:latin typeface="Arial"/>
               </a:rPr>
-              <a:t>Head of Trade Finance Ops — GIFT IBU / bank trade desk</a:t>
-            </a:r>
-          </a:p>
-          <a:p>
-            <a:pPr algn="l">
+              <a:t>Docs in</a:t>
+            </a:r>
+          </a:p>
+        </p:txBody>
+      </p:sp>
+      <p:sp>
+        <p:nvSpPr>
+          <p:cNvPr id="7" name="Right Arrow 6"/>
+          <p:cNvSpPr/>
+          <p:nvPr/>
+        </p:nvSpPr>
+        <p:spPr>
+          <a:xfrm>
+            <a:off x="5055488" y="2606040"/>
+            <a:ext cx="201168" cy="146304"/>
+          </a:xfrm>
+          <a:prstGeom prst="rightArrow">
+            <a:avLst/>
+          </a:prstGeom>
+          <a:solidFill>
+            <a:srgbClr val="C45C26"/>
+          </a:solidFill>
+          <a:ln>
+            <a:noFill/>
+          </a:ln>
+        </p:spPr>
+        <p:style>
+          <a:lnRef idx="1">
+            <a:schemeClr val="accent1"/>
+          </a:lnRef>
+          <a:fillRef idx="3">
+            <a:schemeClr val="accent1"/>
+          </a:fillRef>
+          <a:effectRef idx="2">
+            <a:schemeClr val="accent1"/>
+          </a:effectRef>
+          <a:fontRef idx="minor">
+            <a:schemeClr val="lt1"/>
+          </a:fontRef>
+        </p:style>
+        <p:txBody>
+          <a:bodyPr rtlCol="0" anchor="ctr"/>
+          <a:lstStyle/>
+          <a:p>
+            <a:pPr algn="ctr"/>
+          </a:p>
+        </p:txBody>
+      </p:sp>
+      <p:sp>
+        <p:nvSpPr>
+          <p:cNvPr id="8" name="Rounded Rectangle 7"/>
+          <p:cNvSpPr/>
+          <p:nvPr/>
+        </p:nvSpPr>
+        <p:spPr>
+          <a:xfrm>
+            <a:off x="5256656" y="2414016"/>
+            <a:ext cx="738606" cy="530352"/>
+          </a:xfrm>
+          <a:prstGeom prst="roundRect">
+            <a:avLst/>
+          </a:prstGeom>
+          <a:solidFill>
+            <a:srgbClr val="F1F5F9"/>
+          </a:solidFill>
+          <a:ln w="12700">
+            <a:solidFill>
+              <a:srgbClr val="0B1F33"/>
+            </a:solidFill>
+          </a:ln>
+        </p:spPr>
+        <p:style>
+          <a:lnRef idx="1">
+            <a:schemeClr val="accent1"/>
+          </a:lnRef>
+          <a:fillRef idx="3">
+            <a:schemeClr val="accent1"/>
+          </a:fillRef>
+          <a:effectRef idx="2">
+            <a:schemeClr val="accent1"/>
+          </a:effectRef>
+          <a:fontRef idx="minor">
+            <a:schemeClr val="lt1"/>
+          </a:fontRef>
+        </p:style>
+        <p:txBody>
+          <a:bodyPr rtlCol="0" anchor="ctr" wrap="square" lIns="36576" rIns="36576" tIns="36576" bIns="36576"/>
+          <a:lstStyle/>
+          <a:p>
+            <a:pPr algn="ctr"/>
+            <a:r>
+              <a:rPr sz="800" b="1" i="0">
+                <a:solidFill>
+                  <a:srgbClr val="0B1F33"/>
+                </a:solidFill>
+                <a:latin typeface="Arial"/>
+              </a:rPr>
+              <a:t>Double-
+check</a:t>
+            </a:r>
+          </a:p>
+        </p:txBody>
+      </p:sp>
+      <p:sp>
+        <p:nvSpPr>
+          <p:cNvPr id="9" name="Right Arrow 8"/>
+          <p:cNvSpPr/>
+          <p:nvPr/>
+        </p:nvSpPr>
+        <p:spPr>
+          <a:xfrm>
+            <a:off x="5995263" y="2606040"/>
+            <a:ext cx="201168" cy="146304"/>
+          </a:xfrm>
+          <a:prstGeom prst="rightArrow">
+            <a:avLst/>
+          </a:prstGeom>
+          <a:solidFill>
+            <a:srgbClr val="C45C26"/>
+          </a:solidFill>
+          <a:ln>
+            <a:noFill/>
+          </a:ln>
+        </p:spPr>
+        <p:style>
+          <a:lnRef idx="1">
+            <a:schemeClr val="accent1"/>
+          </a:lnRef>
+          <a:fillRef idx="3">
+            <a:schemeClr val="accent1"/>
+          </a:fillRef>
+          <a:effectRef idx="2">
+            <a:schemeClr val="accent1"/>
+          </a:effectRef>
+          <a:fontRef idx="minor">
+            <a:schemeClr val="lt1"/>
+          </a:fontRef>
+        </p:style>
+        <p:txBody>
+          <a:bodyPr rtlCol="0" anchor="ctr"/>
+          <a:lstStyle/>
+          <a:p>
+            <a:pPr algn="ctr"/>
+          </a:p>
+        </p:txBody>
+      </p:sp>
+      <p:sp>
+        <p:nvSpPr>
+          <p:cNvPr id="10" name="Rounded Rectangle 9"/>
+          <p:cNvSpPr/>
+          <p:nvPr/>
+        </p:nvSpPr>
+        <p:spPr>
+          <a:xfrm>
+            <a:off x="6196431" y="2414016"/>
+            <a:ext cx="738606" cy="530352"/>
+          </a:xfrm>
+          <a:prstGeom prst="roundRect">
+            <a:avLst/>
+          </a:prstGeom>
+          <a:solidFill>
+            <a:srgbClr val="F1F5F9"/>
+          </a:solidFill>
+          <a:ln w="12700">
+            <a:solidFill>
+              <a:srgbClr val="0B1F33"/>
+            </a:solidFill>
+          </a:ln>
+        </p:spPr>
+        <p:style>
+          <a:lnRef idx="1">
+            <a:schemeClr val="accent1"/>
+          </a:lnRef>
+          <a:fillRef idx="3">
+            <a:schemeClr val="accent1"/>
+          </a:fillRef>
+          <a:effectRef idx="2">
+            <a:schemeClr val="accent1"/>
+          </a:effectRef>
+          <a:fontRef idx="minor">
+            <a:schemeClr val="lt1"/>
+          </a:fontRef>
+        </p:style>
+        <p:txBody>
+          <a:bodyPr rtlCol="0" anchor="ctr" wrap="square" lIns="36576" rIns="36576" tIns="36576" bIns="36576"/>
+          <a:lstStyle/>
+          <a:p>
+            <a:pPr algn="ctr"/>
+            <a:r>
+              <a:rPr sz="800" b="1" i="0">
+                <a:solidFill>
+                  <a:srgbClr val="0B1F33"/>
+                </a:solidFill>
+                <a:latin typeface="Arial"/>
+              </a:rPr>
+              <a:t>Flag
+gaps</a:t>
+            </a:r>
+          </a:p>
+        </p:txBody>
+      </p:sp>
+      <p:sp>
+        <p:nvSpPr>
+          <p:cNvPr id="11" name="Right Arrow 10"/>
+          <p:cNvSpPr/>
+          <p:nvPr/>
+        </p:nvSpPr>
+        <p:spPr>
+          <a:xfrm>
+            <a:off x="6935038" y="2606040"/>
+            <a:ext cx="201168" cy="146304"/>
+          </a:xfrm>
+          <a:prstGeom prst="rightArrow">
+            <a:avLst/>
+          </a:prstGeom>
+          <a:solidFill>
+            <a:srgbClr val="C45C26"/>
+          </a:solidFill>
+          <a:ln>
+            <a:noFill/>
+          </a:ln>
+        </p:spPr>
+        <p:style>
+          <a:lnRef idx="1">
+            <a:schemeClr val="accent1"/>
+          </a:lnRef>
+          <a:fillRef idx="3">
+            <a:schemeClr val="accent1"/>
+          </a:fillRef>
+          <a:effectRef idx="2">
+            <a:schemeClr val="accent1"/>
+          </a:effectRef>
+          <a:fontRef idx="minor">
+            <a:schemeClr val="lt1"/>
+          </a:fontRef>
+        </p:style>
+        <p:txBody>
+          <a:bodyPr rtlCol="0" anchor="ctr"/>
+          <a:lstStyle/>
+          <a:p>
+            <a:pPr algn="ctr"/>
+          </a:p>
+        </p:txBody>
+      </p:sp>
+      <p:sp>
+        <p:nvSpPr>
+          <p:cNvPr id="12" name="Rounded Rectangle 11"/>
+          <p:cNvSpPr/>
+          <p:nvPr/>
+        </p:nvSpPr>
+        <p:spPr>
+          <a:xfrm>
+            <a:off x="7136206" y="2414016"/>
+            <a:ext cx="738606" cy="530352"/>
+          </a:xfrm>
+          <a:prstGeom prst="roundRect">
+            <a:avLst/>
+          </a:prstGeom>
+          <a:solidFill>
+            <a:srgbClr val="F1F5F9"/>
+          </a:solidFill>
+          <a:ln w="12700">
+            <a:solidFill>
+              <a:srgbClr val="0B1F33"/>
+            </a:solidFill>
+          </a:ln>
+        </p:spPr>
+        <p:style>
+          <a:lnRef idx="1">
+            <a:schemeClr val="accent1"/>
+          </a:lnRef>
+          <a:fillRef idx="3">
+            <a:schemeClr val="accent1"/>
+          </a:fillRef>
+          <a:effectRef idx="2">
+            <a:schemeClr val="accent1"/>
+          </a:effectRef>
+          <a:fontRef idx="minor">
+            <a:schemeClr val="lt1"/>
+          </a:fontRef>
+        </p:style>
+        <p:txBody>
+          <a:bodyPr rtlCol="0" anchor="ctr" wrap="square" lIns="36576" rIns="36576" tIns="36576" bIns="36576"/>
+          <a:lstStyle/>
+          <a:p>
+            <a:pPr algn="ctr"/>
+            <a:r>
+              <a:rPr sz="800" b="1" i="0">
+                <a:solidFill>
+                  <a:srgbClr val="0B1F33"/>
+                </a:solidFill>
+                <a:latin typeface="Arial"/>
+              </a:rPr>
+              <a:t>Officer
+decides</a:t>
+            </a:r>
+          </a:p>
+        </p:txBody>
+      </p:sp>
+      <p:sp>
+        <p:nvSpPr>
+          <p:cNvPr id="13" name="TextBox 12"/>
+          <p:cNvSpPr txBox="1"/>
+          <p:nvPr/>
+        </p:nvSpPr>
+        <p:spPr>
+          <a:xfrm>
+            <a:off x="4316882" y="2999232"/>
+            <a:ext cx="3557930" cy="320040"/>
+          </a:xfrm>
+          <a:prstGeom prst="rect">
+            <a:avLst/>
+          </a:prstGeom>
+          <a:noFill/>
+        </p:spPr>
+        <p:txBody>
+          <a:bodyPr wrap="square" lIns="73152" rIns="73152" anchor="t">
+            <a:noAutofit/>
+          </a:bodyPr>
+          <a:lstStyle/>
+          <a:p>
+            <a:pPr algn="ctr">
               <a:spcBef>
                 <a:spcPts val="0"/>
               </a:spcBef>
@@ -4280,84 +3869,27 @@
               </a:spcAft>
             </a:pPr>
             <a:r>
-              <a:rPr sz="900" b="1" i="0">
-                <a:solidFill>
-                  <a:srgbClr val="E9631D"/>
+              <a:rPr sz="750" b="0" i="1">
+                <a:solidFill>
+                  <a:srgbClr val="C45C26"/>
                 </a:solidFill>
                 <a:latin typeface="Arial"/>
               </a:rPr>
-              <a:t>Insight</a:t>
-            </a:r>
-          </a:p>
-          <a:p>
-            <a:pPr algn="l">
-              <a:spcBef>
-                <a:spcPts val="0"/>
-              </a:spcBef>
-              <a:spcAft>
-                <a:spcPts val="800"/>
-              </a:spcAft>
-            </a:pPr>
-            <a:r>
-              <a:rPr sz="900" b="0" i="0">
-                <a:solidFill>
-                  <a:srgbClr val="000000"/>
-                </a:solidFill>
-                <a:latin typeface="Arial"/>
-              </a:rPr>
-              <a:t>Banks review paperwork — not the physical container. A look-alike name is not proof.</a:t>
-            </a:r>
-          </a:p>
-          <a:p>
-            <a:pPr algn="l">
-              <a:spcBef>
-                <a:spcPts val="0"/>
-              </a:spcBef>
-              <a:spcAft>
-                <a:spcPts val="200"/>
-              </a:spcAft>
-            </a:pPr>
-            <a:r>
-              <a:rPr sz="900" b="1" i="0">
-                <a:solidFill>
-                  <a:srgbClr val="E9631D"/>
-                </a:solidFill>
-                <a:latin typeface="Arial"/>
-              </a:rPr>
-              <a:t>Evidence</a:t>
-            </a:r>
-          </a:p>
-          <a:p>
-            <a:pPr algn="l">
-              <a:spcBef>
-                <a:spcPts val="0"/>
-              </a:spcBef>
-              <a:spcAft>
-                <a:spcPts val="0"/>
-              </a:spcAft>
-            </a:pPr>
-            <a:r>
-              <a:rPr sz="900" b="0" i="0">
-                <a:solidFill>
-                  <a:srgbClr val="000000"/>
-                </a:solidFill>
-                <a:latin typeface="Arial"/>
-              </a:rPr>
-              <a:t>Live demo on AWS (Mumbai) — open a case, see mismatches, download the handoff pack</a:t>
-            </a:r>
-          </a:p>
-        </p:txBody>
-      </p:sp>
-      <p:sp>
-        <p:nvSpPr>
-          <p:cNvPr id="17" name="Rectangle 16"/>
+              <a:t>Humans stay in charge — TradePulse prepares the file</a:t>
+            </a:r>
+          </a:p>
+        </p:txBody>
+      </p:sp>
+      <p:sp>
+        <p:nvSpPr>
+          <p:cNvPr id="14" name="Rectangle 13"/>
           <p:cNvSpPr/>
           <p:nvPr/>
         </p:nvSpPr>
         <p:spPr>
           <a:xfrm>
-            <a:off x="292608" y="3995928"/>
-            <a:ext cx="3807866" cy="1234440"/>
+            <a:off x="8094268" y="1453896"/>
+            <a:ext cx="3777386" cy="2423160"/>
           </a:xfrm>
           <a:prstGeom prst="rect">
             <a:avLst/>
@@ -4386,7 +3918,9 @@
           </a:fontRef>
         </p:style>
         <p:txBody>
-          <a:bodyPr rtlCol="0" anchor="t" wrap="square" lIns="73152" rIns="73152"/>
+          <a:bodyPr rtlCol="0" anchor="t" wrap="square" lIns="73152" rIns="73152">
+            <a:noAutofit/>
+          </a:bodyPr>
           <a:lstStyle/>
           <a:p>
             <a:pPr algn="l">
@@ -4400,11 +3934,11 @@
             <a:r>
               <a:rPr sz="1100" b="1" i="0">
                 <a:solidFill>
-                  <a:srgbClr val="0B1F33"/>
+                  <a:srgbClr val="000000"/>
                 </a:solidFill>
                 <a:latin typeface="Arial"/>
               </a:rPr>
-              <a:t>4. Regulatory</a:t>
+              <a:t>3. Validation</a:t>
             </a:r>
           </a:p>
           <a:p>
@@ -4417,13 +3951,13 @@
               </a:spcAft>
             </a:pPr>
             <a:r>
-              <a:rPr sz="850" b="0" i="0">
+              <a:rPr sz="900" b="0" i="0">
                 <a:solidFill>
                   <a:srgbClr val="000000"/>
                 </a:solidFill>
                 <a:latin typeface="Arial"/>
               </a:rPr>
-              <a:t>IFSCA / GIFT + bank trade ops (RBI)</a:t>
+              <a:t>• Buyer locked: GIFT IBU / bank trade desk Ops head</a:t>
             </a:r>
           </a:p>
           <a:p>
@@ -4436,13 +3970,13 @@
               </a:spcAft>
             </a:pPr>
             <a:r>
-              <a:rPr sz="850" b="0" i="0">
+              <a:rPr sz="900" b="0" i="0">
                 <a:solidFill>
                   <a:srgbClr val="000000"/>
                 </a:solidFill>
                 <a:latin typeface="Arial"/>
               </a:rPr>
-              <a:t>We never say “AI approved / cleared / sanctioned”</a:t>
+              <a:t>• Banks review paperwork — not the physical cargo</a:t>
             </a:r>
           </a:p>
           <a:p>
@@ -4451,17 +3985,182 @@
                 <a:spcPts val="0"/>
               </a:spcBef>
               <a:spcAft>
-                <a:spcPts val="0"/>
+                <a:spcPts val="200"/>
               </a:spcAft>
             </a:pPr>
             <a:r>
-              <a:rPr sz="850" b="0" i="0">
+              <a:rPr sz="900" b="0" i="0">
                 <a:solidFill>
                   <a:srgbClr val="000000"/>
                 </a:solidFill>
                 <a:latin typeface="Arial"/>
               </a:rPr>
-              <a:t>Officers stay in the loop — always</a:t>
+              <a:t>• Proof: live AWS demo (Mumbai), demo data labelled</a:t>
+            </a:r>
+          </a:p>
+        </p:txBody>
+      </p:sp>
+      <p:sp>
+        <p:nvSpPr>
+          <p:cNvPr id="15" name="Rounded Rectangle 14"/>
+          <p:cNvSpPr/>
+          <p:nvPr/>
+        </p:nvSpPr>
+        <p:spPr>
+          <a:xfrm>
+            <a:off x="8203996" y="2688336"/>
+            <a:ext cx="1137208" cy="502920"/>
+          </a:xfrm>
+          <a:prstGeom prst="roundRect">
+            <a:avLst/>
+          </a:prstGeom>
+          <a:solidFill>
+            <a:srgbClr val="FFFFFF"/>
+          </a:solidFill>
+          <a:ln w="12700">
+            <a:solidFill>
+              <a:srgbClr val="0B1F33"/>
+            </a:solidFill>
+          </a:ln>
+        </p:spPr>
+        <p:style>
+          <a:lnRef idx="1">
+            <a:schemeClr val="accent1"/>
+          </a:lnRef>
+          <a:fillRef idx="3">
+            <a:schemeClr val="accent1"/>
+          </a:fillRef>
+          <a:effectRef idx="2">
+            <a:schemeClr val="accent1"/>
+          </a:effectRef>
+          <a:fontRef idx="minor">
+            <a:schemeClr val="lt1"/>
+          </a:fontRef>
+        </p:style>
+        <p:txBody>
+          <a:bodyPr rtlCol="0" anchor="ctr" wrap="square" lIns="36576" rIns="36576" tIns="36576" bIns="36576"/>
+          <a:lstStyle/>
+          <a:p>
+            <a:pPr algn="ctr"/>
+            <a:r>
+              <a:rPr sz="800" b="1" i="0">
+                <a:solidFill>
+                  <a:srgbClr val="0B1F33"/>
+                </a:solidFill>
+                <a:latin typeface="Arial"/>
+              </a:rPr>
+              <a:t>Live
+demo</a:t>
+            </a:r>
+          </a:p>
+        </p:txBody>
+      </p:sp>
+      <p:sp>
+        <p:nvSpPr>
+          <p:cNvPr id="16" name="Rounded Rectangle 15"/>
+          <p:cNvSpPr/>
+          <p:nvPr/>
+        </p:nvSpPr>
+        <p:spPr>
+          <a:xfrm>
+            <a:off x="9414357" y="2688336"/>
+            <a:ext cx="1137208" cy="502920"/>
+          </a:xfrm>
+          <a:prstGeom prst="roundRect">
+            <a:avLst/>
+          </a:prstGeom>
+          <a:solidFill>
+            <a:srgbClr val="FFFFFF"/>
+          </a:solidFill>
+          <a:ln w="12700">
+            <a:solidFill>
+              <a:srgbClr val="0B1F33"/>
+            </a:solidFill>
+          </a:ln>
+        </p:spPr>
+        <p:style>
+          <a:lnRef idx="1">
+            <a:schemeClr val="accent1"/>
+          </a:lnRef>
+          <a:fillRef idx="3">
+            <a:schemeClr val="accent1"/>
+          </a:fillRef>
+          <a:effectRef idx="2">
+            <a:schemeClr val="accent1"/>
+          </a:effectRef>
+          <a:fontRef idx="minor">
+            <a:schemeClr val="lt1"/>
+          </a:fontRef>
+        </p:style>
+        <p:txBody>
+          <a:bodyPr rtlCol="0" anchor="ctr" wrap="square" lIns="36576" rIns="36576" tIns="36576" bIns="36576"/>
+          <a:lstStyle/>
+          <a:p>
+            <a:pPr algn="ctr"/>
+            <a:r>
+              <a:rPr sz="800" b="1" i="0">
+                <a:solidFill>
+                  <a:srgbClr val="0B1F33"/>
+                </a:solidFill>
+                <a:latin typeface="Arial"/>
+              </a:rPr>
+              <a:t>Sample
+cases</a:t>
+            </a:r>
+          </a:p>
+        </p:txBody>
+      </p:sp>
+      <p:sp>
+        <p:nvSpPr>
+          <p:cNvPr id="17" name="Rounded Rectangle 16"/>
+          <p:cNvSpPr/>
+          <p:nvPr/>
+        </p:nvSpPr>
+        <p:spPr>
+          <a:xfrm>
+            <a:off x="10624718" y="2688336"/>
+            <a:ext cx="1137208" cy="502920"/>
+          </a:xfrm>
+          <a:prstGeom prst="roundRect">
+            <a:avLst/>
+          </a:prstGeom>
+          <a:solidFill>
+            <a:srgbClr val="FFFFFF"/>
+          </a:solidFill>
+          <a:ln w="12700">
+            <a:solidFill>
+              <a:srgbClr val="0B1F33"/>
+            </a:solidFill>
+          </a:ln>
+        </p:spPr>
+        <p:style>
+          <a:lnRef idx="1">
+            <a:schemeClr val="accent1"/>
+          </a:lnRef>
+          <a:fillRef idx="3">
+            <a:schemeClr val="accent1"/>
+          </a:fillRef>
+          <a:effectRef idx="2">
+            <a:schemeClr val="accent1"/>
+          </a:effectRef>
+          <a:fontRef idx="minor">
+            <a:schemeClr val="lt1"/>
+          </a:fontRef>
+        </p:style>
+        <p:txBody>
+          <a:bodyPr rtlCol="0" anchor="ctr" wrap="square" lIns="36576" rIns="36576" tIns="36576" bIns="36576"/>
+          <a:lstStyle/>
+          <a:p>
+            <a:pPr algn="ctr"/>
+            <a:r>
+              <a:rPr sz="800" b="1" i="0">
+                <a:solidFill>
+                  <a:srgbClr val="0B1F33"/>
+                </a:solidFill>
+                <a:latin typeface="Arial"/>
+              </a:rPr>
+              <a:t>Handoff
+pack</a:t>
             </a:r>
           </a:p>
         </p:txBody>
@@ -4474,8 +4173,8 @@
         </p:nvSpPr>
         <p:spPr>
           <a:xfrm>
-            <a:off x="4191914" y="3995928"/>
-            <a:ext cx="3807866" cy="1234440"/>
+            <a:off x="320040" y="3986784"/>
+            <a:ext cx="5720943" cy="1234440"/>
           </a:xfrm>
           <a:prstGeom prst="rect">
             <a:avLst/>
@@ -4504,7 +4203,9 @@
           </a:fontRef>
         </p:style>
         <p:txBody>
-          <a:bodyPr rtlCol="0" anchor="t" wrap="square" lIns="73152" rIns="73152"/>
+          <a:bodyPr rtlCol="0" anchor="t" wrap="square" lIns="73152" rIns="73152">
+            <a:noAutofit/>
+          </a:bodyPr>
           <a:lstStyle/>
           <a:p>
             <a:pPr algn="l">
@@ -4518,11 +4219,11 @@
             <a:r>
               <a:rPr sz="1100" b="1" i="0">
                 <a:solidFill>
-                  <a:srgbClr val="0B1F33"/>
+                  <a:srgbClr val="000000"/>
                 </a:solidFill>
                 <a:latin typeface="Arial"/>
               </a:rPr>
-              <a:t>5. Team</a:t>
+              <a:t>4. Regulatory Requirements (Domestic/IFSC)</a:t>
             </a:r>
           </a:p>
           <a:p>
@@ -4535,13 +4236,13 @@
               </a:spcAft>
             </a:pPr>
             <a:r>
-              <a:rPr sz="850" b="0" i="0">
+              <a:rPr sz="900" b="0" i="0">
                 <a:solidFill>
                   <a:srgbClr val="000000"/>
                 </a:solidFill>
                 <a:latin typeface="Arial"/>
               </a:rPr>
-              <a:t>Abhishek — platform   ·   Ansh — product</a:t>
+              <a:t>• IFSCA / GIFT trade desks · bank ops under RBI</a:t>
             </a:r>
           </a:p>
           <a:p>
@@ -4554,13 +4255,13 @@
               </a:spcAft>
             </a:pPr>
             <a:r>
-              <a:rPr sz="850" b="0" i="0">
+              <a:rPr sz="900" b="0" i="0">
                 <a:solidFill>
                   <a:srgbClr val="000000"/>
                 </a:solidFill>
                 <a:latin typeface="Arial"/>
               </a:rPr>
-              <a:t>Atharva — UI   ·   Shivansh — quality</a:t>
+              <a:t>• We never claim: AI approved / cleared / sanctioned</a:t>
             </a:r>
           </a:p>
           <a:p>
@@ -4573,13 +4274,13 @@
               </a:spcAft>
             </a:pPr>
             <a:r>
-              <a:rPr sz="850" b="1" i="0">
+              <a:rPr sz="900" b="0" i="0">
                 <a:solidFill>
                   <a:srgbClr val="000000"/>
                 </a:solidFill>
                 <a:latin typeface="Arial"/>
               </a:rPr>
-              <a:t>Win: live clickable demo for officers today</a:t>
+              <a:t>• Officers stay in the loop on every material gap</a:t>
             </a:r>
           </a:p>
         </p:txBody>
@@ -4592,18 +4293,18 @@
         </p:nvSpPr>
         <p:spPr>
           <a:xfrm>
-            <a:off x="8091220" y="3995928"/>
-            <a:ext cx="3807866" cy="1234440"/>
+            <a:off x="6150711" y="3986784"/>
+            <a:ext cx="5720943" cy="1234440"/>
           </a:xfrm>
           <a:prstGeom prst="rect">
             <a:avLst/>
           </a:prstGeom>
           <a:solidFill>
-            <a:srgbClr val="F4F7FA"/>
+            <a:srgbClr val="FFFFFF"/>
           </a:solidFill>
           <a:ln w="12700">
             <a:solidFill>
-              <a:srgbClr val="E9631D"/>
+              <a:srgbClr val="000000"/>
             </a:solidFill>
           </a:ln>
         </p:spPr>
@@ -4622,7 +4323,9 @@
           </a:fontRef>
         </p:style>
         <p:txBody>
-          <a:bodyPr rtlCol="0" anchor="t" wrap="square" lIns="73152" rIns="73152"/>
+          <a:bodyPr rtlCol="0" anchor="t" wrap="square" lIns="73152" rIns="73152">
+            <a:noAutofit/>
+          </a:bodyPr>
           <a:lstStyle/>
           <a:p>
             <a:pPr algn="l">
@@ -4636,11 +4339,49 @@
             <a:r>
               <a:rPr sz="1100" b="1" i="0">
                 <a:solidFill>
-                  <a:srgbClr val="E9631D"/>
+                  <a:srgbClr val="000000"/>
                 </a:solidFill>
                 <a:latin typeface="Arial"/>
               </a:rPr>
-              <a:t>Why GIFT IFIH?</a:t>
+              <a:t>5. Team-Market Fit</a:t>
+            </a:r>
+          </a:p>
+          <a:p>
+            <a:pPr algn="l">
+              <a:spcBef>
+                <a:spcPts val="0"/>
+              </a:spcBef>
+              <a:spcAft>
+                <a:spcPts val="300"/>
+              </a:spcAft>
+            </a:pPr>
+            <a:r>
+              <a:rPr sz="900" b="0" i="0">
+                <a:solidFill>
+                  <a:srgbClr val="000000"/>
+                </a:solidFill>
+                <a:latin typeface="Arial"/>
+              </a:rPr>
+              <a:t>• Abhishek platform · Ansh product · Atharva UI · Shivansh QA</a:t>
+            </a:r>
+          </a:p>
+          <a:p>
+            <a:pPr algn="l">
+              <a:spcBef>
+                <a:spcPts val="0"/>
+              </a:spcBef>
+              <a:spcAft>
+                <a:spcPts val="300"/>
+              </a:spcAft>
+            </a:pPr>
+            <a:r>
+              <a:rPr sz="900" b="0" i="0">
+                <a:solidFill>
+                  <a:srgbClr val="000000"/>
+                </a:solidFill>
+                <a:latin typeface="Arial"/>
+              </a:rPr>
+              <a:t>• Clear owners — we don’t invent answers mid-demo</a:t>
             </a:r>
           </a:p>
           <a:p>
@@ -4653,27 +4394,109 @@
               </a:spcAft>
             </a:pPr>
             <a:r>
-              <a:rPr sz="850" b="0" i="0">
+              <a:rPr sz="900" b="0" i="0">
                 <a:solidFill>
                   <a:srgbClr val="000000"/>
                 </a:solidFill>
                 <a:latin typeface="Arial"/>
               </a:rPr>
-              <a:t>Desk intros + mentors + path to a supervised bank pilot for GIFT trade ops</a:t>
-            </a:r>
-          </a:p>
-        </p:txBody>
-      </p:sp>
-      <p:sp>
-        <p:nvSpPr>
-          <p:cNvPr id="20" name="TextBox 19"/>
+              <a:t>• Win: live cloud desk officers can click today</a:t>
+            </a:r>
+          </a:p>
+        </p:txBody>
+      </p:sp>
+      <p:sp>
+        <p:nvSpPr>
+          <p:cNvPr id="20" name="Rectangle 19"/>
+          <p:cNvSpPr/>
+          <p:nvPr/>
+        </p:nvSpPr>
+        <p:spPr>
+          <a:xfrm>
+            <a:off x="320040" y="5330952"/>
+            <a:ext cx="11551615" cy="868680"/>
+          </a:xfrm>
+          <a:prstGeom prst="rect">
+            <a:avLst/>
+          </a:prstGeom>
+          <a:solidFill>
+            <a:srgbClr val="FFFFFF"/>
+          </a:solidFill>
+          <a:ln w="12700">
+            <a:solidFill>
+              <a:srgbClr val="000000"/>
+            </a:solidFill>
+          </a:ln>
+        </p:spPr>
+        <p:style>
+          <a:lnRef idx="1">
+            <a:schemeClr val="accent1"/>
+          </a:lnRef>
+          <a:fillRef idx="3">
+            <a:schemeClr val="accent1"/>
+          </a:fillRef>
+          <a:effectRef idx="2">
+            <a:schemeClr val="accent1"/>
+          </a:effectRef>
+          <a:fontRef idx="minor">
+            <a:schemeClr val="lt1"/>
+          </a:fontRef>
+        </p:style>
+        <p:txBody>
+          <a:bodyPr rtlCol="0" anchor="t" wrap="square" lIns="73152" rIns="73152">
+            <a:noAutofit/>
+          </a:bodyPr>
+          <a:lstStyle/>
+          <a:p>
+            <a:pPr algn="ctr">
+              <a:spcBef>
+                <a:spcPts val="0"/>
+              </a:spcBef>
+              <a:spcAft>
+                <a:spcPts val="500"/>
+              </a:spcAft>
+            </a:pPr>
+            <a:r>
+              <a:rPr sz="1200" b="1" i="0">
+                <a:solidFill>
+                  <a:srgbClr val="000000"/>
+                </a:solidFill>
+                <a:latin typeface="Arial"/>
+              </a:rPr>
+              <a:t>Why GIFT IFIH?</a:t>
+            </a:r>
+          </a:p>
+          <a:p>
+            <a:pPr algn="ctr">
+              <a:spcBef>
+                <a:spcPts val="0"/>
+              </a:spcBef>
+              <a:spcAft>
+                <a:spcPts val="0"/>
+              </a:spcAft>
+            </a:pPr>
+            <a:r>
+              <a:rPr sz="900" b="0" i="0">
+                <a:solidFill>
+                  <a:srgbClr val="000000"/>
+                </a:solidFill>
+                <a:latin typeface="Arial"/>
+              </a:rPr>
+              <a:t>• Mentors + GIFT trade-desk intros → path from this prototype to a supervised bank pilot</a:t>
+            </a:r>
+          </a:p>
+        </p:txBody>
+      </p:sp>
+      <p:sp>
+        <p:nvSpPr>
+          <p:cNvPr id="21" name="TextBox 20"/>
           <p:cNvSpPr txBox="1"/>
           <p:nvPr/>
         </p:nvSpPr>
         <p:spPr>
           <a:xfrm>
-            <a:off x="292608" y="6537960"/>
-            <a:ext cx="11606479" cy="256032"/>
+            <a:off x="320040" y="6510528"/>
+            <a:ext cx="11551615" cy="292608"/>
           </a:xfrm>
           <a:prstGeom prst="rect">
             <a:avLst/>
@@ -4682,7 +4505,7 @@
         </p:spPr>
         <p:txBody>
           <a:bodyPr wrap="square" lIns="73152" rIns="73152" anchor="t">
-            <a:spAutoFit/>
+            <a:noAutofit/>
           </a:bodyPr>
           <a:lstStyle/>
           <a:p>
@@ -4701,7 +4524,7 @@
                 </a:solidFill>
                 <a:latin typeface="Arial"/>
               </a:rPr>
-              <a:t>Guide for content — structure &amp; design are yours. Prefer evidence &amp; metrics. Avoid paragraphs.</a:t>
+              <a:t>This is a guide for the content of your slide. Structure, formatting, and design are left to your discretion. Use evidence &amp; metrics wherever possible. Avoid paragraphs.</a:t>
             </a:r>
           </a:p>
         </p:txBody>

</xml_diff>

<commit_message>
docs: expand regulatory and team sections on pitch slide
Co-authored-by: Cursor <cursoragent@cursor.com>
</commit_message>
<xml_diff>
--- a/docs/reports/TradePulse_Young_Builders_Pitch_One_Slide.pptx
+++ b/docs/reports/TradePulse_Young_Builders_Pitch_One_Slide.pptx
@@ -4174,7 +4174,7 @@
         <p:spPr>
           <a:xfrm>
             <a:off x="320040" y="3986784"/>
-            <a:ext cx="5720943" cy="1234440"/>
+            <a:ext cx="5720943" cy="1371600"/>
           </a:xfrm>
           <a:prstGeom prst="rect">
             <a:avLst/>
@@ -4213,7 +4213,7 @@
                 <a:spcPts val="0"/>
               </a:spcBef>
               <a:spcAft>
-                <a:spcPts val="500"/>
+                <a:spcPts val="400"/>
               </a:spcAft>
             </a:pPr>
             <a:r>
@@ -4232,17 +4232,17 @@
                 <a:spcPts val="0"/>
               </a:spcBef>
               <a:spcAft>
-                <a:spcPts val="300"/>
+                <a:spcPts val="200"/>
               </a:spcAft>
             </a:pPr>
             <a:r>
-              <a:rPr sz="900" b="0" i="0">
+              <a:rPr sz="850" b="0" i="0">
                 <a:solidFill>
                   <a:srgbClr val="000000"/>
                 </a:solidFill>
                 <a:latin typeface="Arial"/>
               </a:rPr>
-              <a:t>• IFSCA / GIFT trade desks · bank ops under RBI</a:t>
+              <a:t>• Focus: IFSCA / GIFT City trade desks; bank trade ops under RBI</a:t>
             </a:r>
           </a:p>
           <a:p>
@@ -4251,17 +4251,36 @@
                 <a:spcPts val="0"/>
               </a:spcBef>
               <a:spcAft>
-                <a:spcPts val="300"/>
+                <a:spcPts val="200"/>
               </a:spcAft>
             </a:pPr>
             <a:r>
-              <a:rPr sz="900" b="0" i="0">
+              <a:rPr sz="850" b="0" i="0">
                 <a:solidFill>
                   <a:srgbClr val="000000"/>
                 </a:solidFill>
                 <a:latin typeface="Arial"/>
               </a:rPr>
-              <a:t>• We never claim: AI approved / cleared / sanctioned</a:t>
+              <a:t>• Company ID: use official records when available — look-alike names are not proof</a:t>
+            </a:r>
+          </a:p>
+          <a:p>
+            <a:pPr algn="l">
+              <a:spcBef>
+                <a:spcPts val="0"/>
+              </a:spcBef>
+              <a:spcAft>
+                <a:spcPts val="200"/>
+              </a:spcAft>
+            </a:pPr>
+            <a:r>
+              <a:rPr sz="850" b="0" i="0">
+                <a:solidFill>
+                  <a:srgbClr val="000000"/>
+                </a:solidFill>
+                <a:latin typeface="Arial"/>
+              </a:rPr>
+              <a:t>• We never claim: AI approved / cleared / sanctioned a trade</a:t>
             </a:r>
           </a:p>
           <a:p>
@@ -4274,13 +4293,13 @@
               </a:spcAft>
             </a:pPr>
             <a:r>
-              <a:rPr sz="900" b="0" i="0">
+              <a:rPr sz="850" b="0" i="0">
                 <a:solidFill>
                   <a:srgbClr val="000000"/>
                 </a:solidFill>
                 <a:latin typeface="Arial"/>
               </a:rPr>
-              <a:t>• Officers stay in the loop on every material gap</a:t>
+              <a:t>• Missing papers stay visible — officers stay in the loop on every material gap</a:t>
             </a:r>
           </a:p>
         </p:txBody>
@@ -4294,7 +4313,7 @@
         <p:spPr>
           <a:xfrm>
             <a:off x="6150711" y="3986784"/>
-            <a:ext cx="5720943" cy="1234440"/>
+            <a:ext cx="5720943" cy="1371600"/>
           </a:xfrm>
           <a:prstGeom prst="rect">
             <a:avLst/>
@@ -4333,7 +4352,7 @@
                 <a:spcPts val="0"/>
               </a:spcBef>
               <a:spcAft>
-                <a:spcPts val="500"/>
+                <a:spcPts val="400"/>
               </a:spcAft>
             </a:pPr>
             <a:r>
@@ -4352,17 +4371,17 @@
                 <a:spcPts val="0"/>
               </a:spcBef>
               <a:spcAft>
-                <a:spcPts val="300"/>
+                <a:spcPts val="200"/>
               </a:spcAft>
             </a:pPr>
             <a:r>
-              <a:rPr sz="900" b="0" i="0">
+              <a:rPr sz="850" b="0" i="0">
                 <a:solidFill>
                   <a:srgbClr val="000000"/>
                 </a:solidFill>
                 <a:latin typeface="Arial"/>
               </a:rPr>
-              <a:t>• Abhishek platform · Ansh product · Atharva UI · Shivansh QA</a:t>
+              <a:t>• Abhishek — platform  ·  Ansh — product desk  ·  Atharva — UI  ·  Shivansh — QA</a:t>
             </a:r>
           </a:p>
           <a:p>
@@ -4371,17 +4390,36 @@
                 <a:spcPts val="0"/>
               </a:spcBef>
               <a:spcAft>
-                <a:spcPts val="300"/>
+                <a:spcPts val="200"/>
               </a:spcAft>
             </a:pPr>
             <a:r>
-              <a:rPr sz="900" b="0" i="0">
+              <a:rPr sz="850" b="0" i="0">
                 <a:solidFill>
                   <a:srgbClr val="000000"/>
                 </a:solidFill>
                 <a:latin typeface="Arial"/>
               </a:rPr>
-              <a:t>• Clear owners — we don’t invent answers mid-demo</a:t>
+              <a:t>• Clear owners for every part — we stop when rules conflict, we don’t invent mid-demo</a:t>
+            </a:r>
+          </a:p>
+          <a:p>
+            <a:pPr algn="l">
+              <a:spcBef>
+                <a:spcPts val="0"/>
+              </a:spcBef>
+              <a:spcAft>
+                <a:spcPts val="200"/>
+              </a:spcAft>
+            </a:pPr>
+            <a:r>
+              <a:rPr sz="850" b="0" i="0">
+                <a:solidFill>
+                  <a:srgbClr val="000000"/>
+                </a:solidFill>
+                <a:latin typeface="Arial"/>
+              </a:rPr>
+              <a:t>• Built for the Ops buyer, not a generic “AI chatbot for PDFs” demo</a:t>
             </a:r>
           </a:p>
           <a:p>
@@ -4394,13 +4432,13 @@
               </a:spcAft>
             </a:pPr>
             <a:r>
-              <a:rPr sz="900" b="0" i="0">
+              <a:rPr sz="850" b="0" i="0">
                 <a:solidFill>
                   <a:srgbClr val="000000"/>
                 </a:solidFill>
                 <a:latin typeface="Arial"/>
               </a:rPr>
-              <a:t>• Win: live cloud desk officers can click today</a:t>
+              <a:t>• Biggest win: live cloud review desk officers can open and click today</a:t>
             </a:r>
           </a:p>
         </p:txBody>
@@ -4413,7 +4451,7 @@
         </p:nvSpPr>
         <p:spPr>
           <a:xfrm>
-            <a:off x="320040" y="5330952"/>
+            <a:off x="320040" y="5468112"/>
             <a:ext cx="11551615" cy="868680"/>
           </a:xfrm>
           <a:prstGeom prst="rect">

</xml_diff>

<commit_message>
docs: expand Why GIFT IFIH with visual path and residency framing
Mentors/regulators → trade desks → sandbox path → bank Ops pilot, grounded in IFIH Young Builders program.

Co-authored-by: Cursor <cursoragent@cursor.com>
</commit_message>
<xml_diff>
--- a/docs/reports/TradePulse_Young_Builders_Pitch_One_Slide.pptx
+++ b/docs/reports/TradePulse_Young_Builders_Pitch_One_Slide.pptx
@@ -3240,7 +3240,7 @@
         <p:spPr>
           <a:xfrm>
             <a:off x="320040" y="1453896"/>
-            <a:ext cx="3777386" cy="2423160"/>
+            <a:ext cx="3777386" cy="2331720"/>
           </a:xfrm>
           <a:prstGeom prst="rect">
             <a:avLst/>
@@ -3398,7 +3398,7 @@
         <p:spPr>
           <a:xfrm>
             <a:off x="4207154" y="1453896"/>
-            <a:ext cx="3777386" cy="2423160"/>
+            <a:ext cx="3777386" cy="2331720"/>
           </a:xfrm>
           <a:prstGeom prst="rect">
             <a:avLst/>
@@ -3889,7 +3889,7 @@
         <p:spPr>
           <a:xfrm>
             <a:off x="8094268" y="1453896"/>
-            <a:ext cx="3777386" cy="2423160"/>
+            <a:ext cx="3777386" cy="2331720"/>
           </a:xfrm>
           <a:prstGeom prst="rect">
             <a:avLst/>
@@ -4173,7 +4173,7 @@
         </p:nvSpPr>
         <p:spPr>
           <a:xfrm>
-            <a:off x="320040" y="3986784"/>
+            <a:off x="320040" y="3895344"/>
             <a:ext cx="5720943" cy="1371600"/>
           </a:xfrm>
           <a:prstGeom prst="rect">
@@ -4312,7 +4312,7 @@
         </p:nvSpPr>
         <p:spPr>
           <a:xfrm>
-            <a:off x="6150711" y="3986784"/>
+            <a:off x="6150711" y="3895344"/>
             <a:ext cx="5720943" cy="1371600"/>
           </a:xfrm>
           <a:prstGeom prst="rect">
@@ -4451,8 +4451,8 @@
         </p:nvSpPr>
         <p:spPr>
           <a:xfrm>
-            <a:off x="320040" y="5468112"/>
-            <a:ext cx="11551615" cy="868680"/>
+            <a:off x="320040" y="5376672"/>
+            <a:ext cx="11551615" cy="1143000"/>
           </a:xfrm>
           <a:prstGeom prst="rect">
             <a:avLst/>
@@ -4491,7 +4491,7 @@
                 <a:spcPts val="0"/>
               </a:spcBef>
               <a:spcAft>
-                <a:spcPts val="500"/>
+                <a:spcPts val="200"/>
               </a:spcAft>
             </a:pPr>
             <a:r>
@@ -4504,30 +4504,402 @@
               <a:t>Why GIFT IFIH?</a:t>
             </a:r>
           </a:p>
+        </p:txBody>
+      </p:sp>
+      <p:sp>
+        <p:nvSpPr>
+          <p:cNvPr id="21" name="Rounded Rectangle 20"/>
+          <p:cNvSpPr/>
+          <p:nvPr/>
+        </p:nvSpPr>
+        <p:spPr>
+          <a:xfrm>
+            <a:off x="484632" y="5724144"/>
+            <a:ext cx="2613583" cy="384048"/>
+          </a:xfrm>
+          <a:prstGeom prst="roundRect">
+            <a:avLst/>
+          </a:prstGeom>
+          <a:solidFill>
+            <a:srgbClr val="FFFFFF"/>
+          </a:solidFill>
+          <a:ln w="12700">
+            <a:solidFill>
+              <a:srgbClr val="0B1F33"/>
+            </a:solidFill>
+          </a:ln>
+        </p:spPr>
+        <p:style>
+          <a:lnRef idx="1">
+            <a:schemeClr val="accent1"/>
+          </a:lnRef>
+          <a:fillRef idx="3">
+            <a:schemeClr val="accent1"/>
+          </a:fillRef>
+          <a:effectRef idx="2">
+            <a:schemeClr val="accent1"/>
+          </a:effectRef>
+          <a:fontRef idx="minor">
+            <a:schemeClr val="lt1"/>
+          </a:fontRef>
+        </p:style>
+        <p:txBody>
+          <a:bodyPr rtlCol="0" anchor="ctr" wrap="square" lIns="36576" rIns="36576" tIns="36576" bIns="36576"/>
+          <a:lstStyle/>
+          <a:p>
+            <a:pPr algn="ctr"/>
+            <a:r>
+              <a:rPr sz="800" b="1" i="0">
+                <a:solidFill>
+                  <a:srgbClr val="0B1F33"/>
+                </a:solidFill>
+                <a:latin typeface="Arial"/>
+              </a:rPr>
+              <a:t>Mentors &amp;
+regulators</a:t>
+            </a:r>
+          </a:p>
+        </p:txBody>
+      </p:sp>
+      <p:sp>
+        <p:nvSpPr>
+          <p:cNvPr id="22" name="Right Arrow 21"/>
+          <p:cNvSpPr/>
+          <p:nvPr/>
+        </p:nvSpPr>
+        <p:spPr>
+          <a:xfrm>
+            <a:off x="3098215" y="5852160"/>
+            <a:ext cx="256032" cy="128016"/>
+          </a:xfrm>
+          <a:prstGeom prst="rightArrow">
+            <a:avLst/>
+          </a:prstGeom>
+          <a:solidFill>
+            <a:srgbClr val="C45C26"/>
+          </a:solidFill>
+          <a:ln>
+            <a:noFill/>
+          </a:ln>
+        </p:spPr>
+        <p:style>
+          <a:lnRef idx="1">
+            <a:schemeClr val="accent1"/>
+          </a:lnRef>
+          <a:fillRef idx="3">
+            <a:schemeClr val="accent1"/>
+          </a:fillRef>
+          <a:effectRef idx="2">
+            <a:schemeClr val="accent1"/>
+          </a:effectRef>
+          <a:fontRef idx="minor">
+            <a:schemeClr val="lt1"/>
+          </a:fontRef>
+        </p:style>
+        <p:txBody>
+          <a:bodyPr rtlCol="0" anchor="ctr"/>
+          <a:lstStyle/>
+          <a:p>
+            <a:pPr algn="ctr"/>
+          </a:p>
+        </p:txBody>
+      </p:sp>
+      <p:sp>
+        <p:nvSpPr>
+          <p:cNvPr id="23" name="Rounded Rectangle 22"/>
+          <p:cNvSpPr/>
+          <p:nvPr/>
+        </p:nvSpPr>
+        <p:spPr>
+          <a:xfrm>
+            <a:off x="3354247" y="5724144"/>
+            <a:ext cx="2613583" cy="384048"/>
+          </a:xfrm>
+          <a:prstGeom prst="roundRect">
+            <a:avLst/>
+          </a:prstGeom>
+          <a:solidFill>
+            <a:srgbClr val="FFFFFF"/>
+          </a:solidFill>
+          <a:ln w="12700">
+            <a:solidFill>
+              <a:srgbClr val="0B1F33"/>
+            </a:solidFill>
+          </a:ln>
+        </p:spPr>
+        <p:style>
+          <a:lnRef idx="1">
+            <a:schemeClr val="accent1"/>
+          </a:lnRef>
+          <a:fillRef idx="3">
+            <a:schemeClr val="accent1"/>
+          </a:fillRef>
+          <a:effectRef idx="2">
+            <a:schemeClr val="accent1"/>
+          </a:effectRef>
+          <a:fontRef idx="minor">
+            <a:schemeClr val="lt1"/>
+          </a:fontRef>
+        </p:style>
+        <p:txBody>
+          <a:bodyPr rtlCol="0" anchor="ctr" wrap="square" lIns="36576" rIns="36576" tIns="36576" bIns="36576"/>
+          <a:lstStyle/>
+          <a:p>
+            <a:pPr algn="ctr"/>
+            <a:r>
+              <a:rPr sz="800" b="1" i="0">
+                <a:solidFill>
+                  <a:srgbClr val="0B1F33"/>
+                </a:solidFill>
+                <a:latin typeface="Arial"/>
+              </a:rPr>
+              <a:t>GIFT trade
+desk intros</a:t>
+            </a:r>
+          </a:p>
+        </p:txBody>
+      </p:sp>
+      <p:sp>
+        <p:nvSpPr>
+          <p:cNvPr id="24" name="Right Arrow 23"/>
+          <p:cNvSpPr/>
+          <p:nvPr/>
+        </p:nvSpPr>
+        <p:spPr>
+          <a:xfrm>
+            <a:off x="5967831" y="5852160"/>
+            <a:ext cx="256032" cy="128016"/>
+          </a:xfrm>
+          <a:prstGeom prst="rightArrow">
+            <a:avLst/>
+          </a:prstGeom>
+          <a:solidFill>
+            <a:srgbClr val="C45C26"/>
+          </a:solidFill>
+          <a:ln>
+            <a:noFill/>
+          </a:ln>
+        </p:spPr>
+        <p:style>
+          <a:lnRef idx="1">
+            <a:schemeClr val="accent1"/>
+          </a:lnRef>
+          <a:fillRef idx="3">
+            <a:schemeClr val="accent1"/>
+          </a:fillRef>
+          <a:effectRef idx="2">
+            <a:schemeClr val="accent1"/>
+          </a:effectRef>
+          <a:fontRef idx="minor">
+            <a:schemeClr val="lt1"/>
+          </a:fontRef>
+        </p:style>
+        <p:txBody>
+          <a:bodyPr rtlCol="0" anchor="ctr"/>
+          <a:lstStyle/>
+          <a:p>
+            <a:pPr algn="ctr"/>
+          </a:p>
+        </p:txBody>
+      </p:sp>
+      <p:sp>
+        <p:nvSpPr>
+          <p:cNvPr id="25" name="Rounded Rectangle 24"/>
+          <p:cNvSpPr/>
+          <p:nvPr/>
+        </p:nvSpPr>
+        <p:spPr>
+          <a:xfrm>
+            <a:off x="6223863" y="5724144"/>
+            <a:ext cx="2613583" cy="384048"/>
+          </a:xfrm>
+          <a:prstGeom prst="roundRect">
+            <a:avLst/>
+          </a:prstGeom>
+          <a:solidFill>
+            <a:srgbClr val="FFFFFF"/>
+          </a:solidFill>
+          <a:ln w="12700">
+            <a:solidFill>
+              <a:srgbClr val="0B1F33"/>
+            </a:solidFill>
+          </a:ln>
+        </p:spPr>
+        <p:style>
+          <a:lnRef idx="1">
+            <a:schemeClr val="accent1"/>
+          </a:lnRef>
+          <a:fillRef idx="3">
+            <a:schemeClr val="accent1"/>
+          </a:fillRef>
+          <a:effectRef idx="2">
+            <a:schemeClr val="accent1"/>
+          </a:effectRef>
+          <a:fontRef idx="minor">
+            <a:schemeClr val="lt1"/>
+          </a:fontRef>
+        </p:style>
+        <p:txBody>
+          <a:bodyPr rtlCol="0" anchor="ctr" wrap="square" lIns="36576" rIns="36576" tIns="36576" bIns="36576"/>
+          <a:lstStyle/>
+          <a:p>
+            <a:pPr algn="ctr"/>
+            <a:r>
+              <a:rPr sz="800" b="1" i="0">
+                <a:solidFill>
+                  <a:srgbClr val="0B1F33"/>
+                </a:solidFill>
+                <a:latin typeface="Arial"/>
+              </a:rPr>
+              <a:t>Sandbox /
+pilot path</a:t>
+            </a:r>
+          </a:p>
+        </p:txBody>
+      </p:sp>
+      <p:sp>
+        <p:nvSpPr>
+          <p:cNvPr id="26" name="Right Arrow 25"/>
+          <p:cNvSpPr/>
+          <p:nvPr/>
+        </p:nvSpPr>
+        <p:spPr>
+          <a:xfrm>
+            <a:off x="8837447" y="5852160"/>
+            <a:ext cx="256032" cy="128016"/>
+          </a:xfrm>
+          <a:prstGeom prst="rightArrow">
+            <a:avLst/>
+          </a:prstGeom>
+          <a:solidFill>
+            <a:srgbClr val="C45C26"/>
+          </a:solidFill>
+          <a:ln>
+            <a:noFill/>
+          </a:ln>
+        </p:spPr>
+        <p:style>
+          <a:lnRef idx="1">
+            <a:schemeClr val="accent1"/>
+          </a:lnRef>
+          <a:fillRef idx="3">
+            <a:schemeClr val="accent1"/>
+          </a:fillRef>
+          <a:effectRef idx="2">
+            <a:schemeClr val="accent1"/>
+          </a:effectRef>
+          <a:fontRef idx="minor">
+            <a:schemeClr val="lt1"/>
+          </a:fontRef>
+        </p:style>
+        <p:txBody>
+          <a:bodyPr rtlCol="0" anchor="ctr"/>
+          <a:lstStyle/>
+          <a:p>
+            <a:pPr algn="ctr"/>
+          </a:p>
+        </p:txBody>
+      </p:sp>
+      <p:sp>
+        <p:nvSpPr>
+          <p:cNvPr id="27" name="Rounded Rectangle 26"/>
+          <p:cNvSpPr/>
+          <p:nvPr/>
+        </p:nvSpPr>
+        <p:spPr>
+          <a:xfrm>
+            <a:off x="9093479" y="5724144"/>
+            <a:ext cx="2613583" cy="384048"/>
+          </a:xfrm>
+          <a:prstGeom prst="roundRect">
+            <a:avLst/>
+          </a:prstGeom>
+          <a:solidFill>
+            <a:srgbClr val="FFFFFF"/>
+          </a:solidFill>
+          <a:ln w="12700">
+            <a:solidFill>
+              <a:srgbClr val="0B1F33"/>
+            </a:solidFill>
+          </a:ln>
+        </p:spPr>
+        <p:style>
+          <a:lnRef idx="1">
+            <a:schemeClr val="accent1"/>
+          </a:lnRef>
+          <a:fillRef idx="3">
+            <a:schemeClr val="accent1"/>
+          </a:fillRef>
+          <a:effectRef idx="2">
+            <a:schemeClr val="accent1"/>
+          </a:effectRef>
+          <a:fontRef idx="minor">
+            <a:schemeClr val="lt1"/>
+          </a:fontRef>
+        </p:style>
+        <p:txBody>
+          <a:bodyPr rtlCol="0" anchor="ctr" wrap="square" lIns="36576" rIns="36576" tIns="36576" bIns="36576"/>
+          <a:lstStyle/>
+          <a:p>
+            <a:pPr algn="ctr"/>
+            <a:r>
+              <a:rPr sz="800" b="1" i="0">
+                <a:solidFill>
+                  <a:srgbClr val="0B1F33"/>
+                </a:solidFill>
+                <a:latin typeface="Arial"/>
+              </a:rPr>
+              <a:t>Bank Ops
+pilot</a:t>
+            </a:r>
+          </a:p>
+        </p:txBody>
+      </p:sp>
+      <p:sp>
+        <p:nvSpPr>
+          <p:cNvPr id="28" name="TextBox 27"/>
+          <p:cNvSpPr txBox="1"/>
+          <p:nvPr/>
+        </p:nvSpPr>
+        <p:spPr>
+          <a:xfrm>
+            <a:off x="484632" y="6144768"/>
+            <a:ext cx="11222431" cy="256032"/>
+          </a:xfrm>
+          <a:prstGeom prst="rect">
+            <a:avLst/>
+          </a:prstGeom>
+          <a:noFill/>
+        </p:spPr>
+        <p:txBody>
+          <a:bodyPr wrap="square" lIns="73152" rIns="73152" anchor="t">
+            <a:noAutofit/>
+          </a:bodyPr>
+          <a:lstStyle/>
           <a:p>
             <a:pPr algn="ctr">
               <a:spcBef>
                 <a:spcPts val="0"/>
               </a:spcBef>
               <a:spcAft>
-                <a:spcPts val="0"/>
+                <a:spcPts val="200"/>
               </a:spcAft>
             </a:pPr>
             <a:r>
-              <a:rPr sz="900" b="0" i="0">
-                <a:solidFill>
-                  <a:srgbClr val="000000"/>
+              <a:rPr sz="750" b="0" i="1">
+                <a:solidFill>
+                  <a:srgbClr val="C45C26"/>
                 </a:solidFill>
                 <a:latin typeface="Arial"/>
               </a:rPr>
-              <a:t>• Mentors + GIFT trade-desk intros → path from this prototype to a supervised bank pilot</a:t>
-            </a:r>
-          </a:p>
-        </p:txBody>
-      </p:sp>
-      <p:sp>
-        <p:nvSpPr>
-          <p:cNvPr id="21" name="TextBox 20"/>
+              <a:t>Young Builders → residency + IFSCA exposure → convert tonight’s prototype into a supervised bank pilot</a:t>
+            </a:r>
+          </a:p>
+        </p:txBody>
+      </p:sp>
+      <p:sp>
+        <p:nvSpPr>
+          <p:cNvPr id="29" name="TextBox 28"/>
           <p:cNvSpPr txBox="1"/>
           <p:nvPr/>
         </p:nvSpPr>

</xml_diff>

<commit_message>
docs: add ITFS to pitch slide regulatory section
Name IFSCA International Trade Financing Services platforms in GIFT IFSC focus, in plain officer language.

Co-authored-by: Cursor <cursoragent@cursor.com>
</commit_message>
<xml_diff>
--- a/docs/reports/TradePulse_Young_Builders_Pitch_One_Slide.pptx
+++ b/docs/reports/TradePulse_Young_Builders_Pitch_One_Slide.pptx
@@ -4213,7 +4213,7 @@
                 <a:spcPts val="0"/>
               </a:spcBef>
               <a:spcAft>
-                <a:spcPts val="400"/>
+                <a:spcPts val="300"/>
               </a:spcAft>
             </a:pPr>
             <a:r>
@@ -4236,13 +4236,13 @@
               </a:spcAft>
             </a:pPr>
             <a:r>
-              <a:rPr sz="850" b="0" i="0">
+              <a:rPr sz="800" b="0" i="0">
                 <a:solidFill>
                   <a:srgbClr val="000000"/>
                 </a:solidFill>
                 <a:latin typeface="Arial"/>
               </a:rPr>
-              <a:t>• Focus: IFSCA / GIFT City trade desks; bank trade ops under RBI</a:t>
+              <a:t>• Focus: IFSCA / GIFT City — including ITFS (International Trade Financing Services) platforms for cross-border trade finance</a:t>
             </a:r>
           </a:p>
           <a:p>
@@ -4255,13 +4255,13 @@
               </a:spcAft>
             </a:pPr>
             <a:r>
-              <a:rPr sz="850" b="0" i="0">
+              <a:rPr sz="800" b="0" i="0">
                 <a:solidFill>
                   <a:srgbClr val="000000"/>
                 </a:solidFill>
                 <a:latin typeface="Arial"/>
               </a:rPr>
-              <a:t>• Company ID: use official records when available — look-alike names are not proof</a:t>
+              <a:t>• Also: bank / IBU trade desks under RBI where domestic banking rules apply</a:t>
             </a:r>
           </a:p>
           <a:p>
@@ -4274,13 +4274,13 @@
               </a:spcAft>
             </a:pPr>
             <a:r>
-              <a:rPr sz="850" b="0" i="0">
+              <a:rPr sz="800" b="0" i="0">
                 <a:solidFill>
                   <a:srgbClr val="000000"/>
                 </a:solidFill>
                 <a:latin typeface="Arial"/>
               </a:rPr>
-              <a:t>• We never claim: AI approved / cleared / sanctioned a trade</a:t>
+              <a:t>• Company ID: official records when available — look-alike names are not proof</a:t>
             </a:r>
           </a:p>
           <a:p>
@@ -4293,13 +4293,13 @@
               </a:spcAft>
             </a:pPr>
             <a:r>
-              <a:rPr sz="850" b="0" i="0">
+              <a:rPr sz="800" b="0" i="0">
                 <a:solidFill>
                   <a:srgbClr val="000000"/>
                 </a:solidFill>
                 <a:latin typeface="Arial"/>
               </a:rPr>
-              <a:t>• Missing papers stay visible — officers stay in the loop on every material gap</a:t>
+              <a:t>• We never claim: AI approved / cleared / sanctioned a trade — officers stay in the loop</a:t>
             </a:r>
           </a:p>
         </p:txBody>

</xml_diff>